<commit_message>
docs(pitch): upgrade pitch presentation with rich visual layout, embedded UI screenshots, and presentation runbook
</commit_message>
<xml_diff>
--- a/docs/pitch/Checkout_Radar_AZINHACK_2026.pptx
+++ b/docs/pitch/Checkout_Radar_AZINHACK_2026.pptx
@@ -3148,8 +3148,8 @@
         </p:nvSpPr>
         <p:spPr>
           <a:xfrm>
-            <a:off x="731520" y="731520"/>
-            <a:ext cx="5303520" cy="411480"/>
+            <a:off x="731520" y="640080"/>
+            <a:ext cx="5120640" cy="365760"/>
           </a:xfrm>
           <a:prstGeom prst="roundRect">
             <a:avLst/>
@@ -3178,7 +3178,7 @@
           </a:fontRef>
         </p:style>
         <p:txBody>
-          <a:bodyPr rtlCol="0" anchor="ctr" lIns="182880"/>
+          <a:bodyPr rtlCol="0" anchor="ctr" lIns="137160"/>
           <a:lstStyle/>
           <a:p>
             <a:pPr algn="ctr">
@@ -3203,8 +3203,8 @@
         </p:nvSpPr>
         <p:spPr>
           <a:xfrm>
-            <a:off x="731520" y="1280160"/>
-            <a:ext cx="10698480" cy="2011680"/>
+            <a:off x="731520" y="1188720"/>
+            <a:ext cx="5303520" cy="2926080"/>
           </a:xfrm>
           <a:prstGeom prst="rect">
             <a:avLst/>
@@ -3219,9 +3219,9 @@
           <a:p>
             <a:pPr>
               <a:spcAft>
-                <a:spcPts val="800"/>
-              </a:spcAft>
-              <a:defRPr sz="4400" b="1">
+                <a:spcPts val="600"/>
+              </a:spcAft>
+              <a:defRPr sz="4000" b="1">
                 <a:solidFill>
                   <a:srgbClr val="FFFFFF"/>
                 </a:solidFill>
@@ -3237,7 +3237,7 @@
               <a:spcAft>
                 <a:spcPts val="1000"/>
               </a:spcAft>
-              <a:defRPr sz="2200" b="1">
+              <a:defRPr sz="1800" b="1">
                 <a:solidFill>
                   <a:srgbClr val="38BDF8"/>
                 </a:solidFill>
@@ -3250,7 +3250,7 @@
           </a:p>
           <a:p>
             <a:pPr>
-              <a:defRPr sz="1400">
+              <a:defRPr sz="1300">
                 <a:solidFill>
                   <a:srgbClr val="CBD5E1"/>
                 </a:solidFill>
@@ -3258,7 +3258,7 @@
               </a:defRPr>
             </a:pPr>
             <a:r>
-              <a:t>Deploying autonomous TinyFish browser agents across controlled condition matrices to turn subjective dark pattern claims into reproducible, cryptographic, screenshot-backed empirical evidence.</a:t>
+              <a:t>Deploying autonomous TinyFish browser agents across controlled condition matrices to turn subjective dark pattern claims into reproducible, screenshot-backed empirical proof.</a:t>
             </a:r>
           </a:p>
         </p:txBody>
@@ -3271,8 +3271,8 @@
         </p:nvSpPr>
         <p:spPr>
           <a:xfrm>
-            <a:off x="731520" y="3931920"/>
-            <a:ext cx="2514600" cy="1463040"/>
+            <a:off x="731520" y="4297680"/>
+            <a:ext cx="2514600" cy="868680"/>
           </a:xfrm>
           <a:prstGeom prst="roundRect">
             <a:avLst/>
@@ -3316,8 +3316,8 @@
         </p:nvSpPr>
         <p:spPr>
           <a:xfrm>
-            <a:off x="868680" y="4069080"/>
-            <a:ext cx="2240280" cy="1188720"/>
+            <a:off x="868680" y="4389120"/>
+            <a:ext cx="2240280" cy="685800"/>
           </a:xfrm>
           <a:prstGeom prst="rect">
             <a:avLst/>
@@ -3325,20 +3325,16 @@
           <a:noFill/>
         </p:spPr>
         <p:txBody>
-          <a:bodyPr wrap="square" tIns="0" lIns="0">
+          <a:bodyPr wrap="none" lIns="0" tIns="0">
             <a:spAutoFit/>
           </a:bodyPr>
           <a:lstStyle/>
           <a:p>
             <a:pPr>
-              <a:spcAft>
-                <a:spcPts val="400"/>
-              </a:spcAft>
-              <a:defRPr sz="2800" b="1">
+              <a:defRPr sz="2000" b="1">
                 <a:solidFill>
                   <a:srgbClr val="10B981"/>
                 </a:solidFill>
-                <a:latin typeface="Arial"/>
               </a:defRPr>
             </a:pPr>
             <a:r>
@@ -3347,15 +3343,14 @@
           </a:p>
           <a:p>
             <a:pPr>
-              <a:defRPr sz="1100">
+              <a:defRPr sz="1000">
                 <a:solidFill>
                   <a:srgbClr val="94A3B8"/>
                 </a:solidFill>
-                <a:latin typeface="Arial"/>
-              </a:defRPr>
-            </a:pPr>
-            <a:r>
-              <a:t>Tests Passing (CI Tested)</a:t>
+              </a:defRPr>
+            </a:pPr>
+            <a:r>
+              <a:t>Tests Passing in CI</a:t>
             </a:r>
           </a:p>
         </p:txBody>
@@ -3368,8 +3363,8 @@
         </p:nvSpPr>
         <p:spPr>
           <a:xfrm>
-            <a:off x="3456432" y="3931920"/>
-            <a:ext cx="2514600" cy="1463040"/>
+            <a:off x="3383280" y="4297680"/>
+            <a:ext cx="2514600" cy="868680"/>
           </a:xfrm>
           <a:prstGeom prst="roundRect">
             <a:avLst/>
@@ -3413,8 +3408,8 @@
         </p:nvSpPr>
         <p:spPr>
           <a:xfrm>
-            <a:off x="3593592" y="4069080"/>
-            <a:ext cx="2240280" cy="1188720"/>
+            <a:off x="3520440" y="4389120"/>
+            <a:ext cx="2240280" cy="685800"/>
           </a:xfrm>
           <a:prstGeom prst="rect">
             <a:avLst/>
@@ -3422,33 +3417,28 @@
           <a:noFill/>
         </p:spPr>
         <p:txBody>
-          <a:bodyPr wrap="square" tIns="0" lIns="0">
+          <a:bodyPr wrap="none" lIns="0" tIns="0">
             <a:spAutoFit/>
           </a:bodyPr>
           <a:lstStyle/>
           <a:p>
             <a:pPr>
-              <a:spcAft>
-                <a:spcPts val="400"/>
-              </a:spcAft>
-              <a:defRPr sz="2800" b="1">
+              <a:defRPr sz="2000" b="1">
                 <a:solidFill>
                   <a:srgbClr val="38BDF8"/>
                 </a:solidFill>
-                <a:latin typeface="Arial"/>
-              </a:defRPr>
-            </a:pPr>
-            <a:r>
-              <a:t>3 / 3</a:t>
-            </a:r>
-          </a:p>
-          <a:p>
-            <a:pPr>
-              <a:defRPr sz="1100">
+              </a:defRPr>
+            </a:pPr>
+            <a:r>
+              <a:t>3 / 3 Verified</a:t>
+            </a:r>
+          </a:p>
+          <a:p>
+            <a:pPr>
+              <a:defRPr sz="1000">
                 <a:solidFill>
                   <a:srgbClr val="94A3B8"/>
                 </a:solidFill>
-                <a:latin typeface="Arial"/>
               </a:defRPr>
             </a:pPr>
             <a:r>
@@ -3465,8 +3455,8 @@
         </p:nvSpPr>
         <p:spPr>
           <a:xfrm>
-            <a:off x="6181344" y="3931920"/>
-            <a:ext cx="2514600" cy="1463040"/>
+            <a:off x="731520" y="5303520"/>
+            <a:ext cx="2514600" cy="868680"/>
           </a:xfrm>
           <a:prstGeom prst="roundRect">
             <a:avLst/>
@@ -3510,8 +3500,8 @@
         </p:nvSpPr>
         <p:spPr>
           <a:xfrm>
-            <a:off x="6318504" y="4069080"/>
-            <a:ext cx="2240280" cy="1188720"/>
+            <a:off x="868680" y="5394960"/>
+            <a:ext cx="2240280" cy="685800"/>
           </a:xfrm>
           <a:prstGeom prst="rect">
             <a:avLst/>
@@ -3519,20 +3509,16 @@
           <a:noFill/>
         </p:spPr>
         <p:txBody>
-          <a:bodyPr wrap="square" tIns="0" lIns="0">
+          <a:bodyPr wrap="none" lIns="0" tIns="0">
             <a:spAutoFit/>
           </a:bodyPr>
           <a:lstStyle/>
           <a:p>
             <a:pPr>
-              <a:spcAft>
-                <a:spcPts val="400"/>
-              </a:spcAft>
-              <a:defRPr sz="2800" b="1">
+              <a:defRPr sz="2000" b="1">
                 <a:solidFill>
                   <a:srgbClr val="3B82F6"/>
                 </a:solidFill>
-                <a:latin typeface="Arial"/>
               </a:defRPr>
             </a:pPr>
             <a:r>
@@ -3541,15 +3527,14 @@
           </a:p>
           <a:p>
             <a:pPr>
-              <a:defRPr sz="1100">
+              <a:defRPr sz="1000">
                 <a:solidFill>
                   <a:srgbClr val="94A3B8"/>
                 </a:solidFill>
-                <a:latin typeface="Arial"/>
-              </a:defRPr>
-            </a:pPr>
-            <a:r>
-              <a:t>Cryptographic Chain of Custody</a:t>
+              </a:defRPr>
+            </a:pPr>
+            <a:r>
+              <a:t>Cryptographic Custody</a:t>
             </a:r>
           </a:p>
         </p:txBody>
@@ -3562,8 +3547,8 @@
         </p:nvSpPr>
         <p:spPr>
           <a:xfrm>
-            <a:off x="8906256" y="3931920"/>
-            <a:ext cx="2514600" cy="1463040"/>
+            <a:off x="3383280" y="5303520"/>
+            <a:ext cx="2514600" cy="868680"/>
           </a:xfrm>
           <a:prstGeom prst="roundRect">
             <a:avLst/>
@@ -3607,8 +3592,124 @@
         </p:nvSpPr>
         <p:spPr>
           <a:xfrm>
-            <a:off x="9043416" y="4069080"/>
-            <a:ext cx="2240280" cy="1188720"/>
+            <a:off x="3520440" y="5394960"/>
+            <a:ext cx="2240280" cy="685800"/>
+          </a:xfrm>
+          <a:prstGeom prst="rect">
+            <a:avLst/>
+          </a:prstGeom>
+          <a:noFill/>
+        </p:spPr>
+        <p:txBody>
+          <a:bodyPr wrap="none" lIns="0" tIns="0">
+            <a:spAutoFit/>
+          </a:bodyPr>
+          <a:lstStyle/>
+          <a:p>
+            <a:pPr>
+              <a:defRPr sz="2000" b="1">
+                <a:solidFill>
+                  <a:srgbClr val="8B5CF6"/>
+                </a:solidFill>
+              </a:defRPr>
+            </a:pPr>
+            <a:r>
+              <a:t>$0.00 Cost</a:t>
+            </a:r>
+          </a:p>
+          <a:p>
+            <a:pPr>
+              <a:defRPr sz="1000">
+                <a:solidFill>
+                  <a:srgbClr val="94A3B8"/>
+                </a:solidFill>
+              </a:defRPr>
+            </a:pPr>
+            <a:r>
+              <a:t>Deterministic Offline Mock</a:t>
+            </a:r>
+          </a:p>
+        </p:txBody>
+      </p:sp>
+      <p:sp>
+        <p:nvSpPr>
+          <p:cNvPr id="13" name="Rounded Rectangle 12"/>
+          <p:cNvSpPr/>
+          <p:nvPr/>
+        </p:nvSpPr>
+        <p:spPr>
+          <a:xfrm>
+            <a:off x="6217920" y="822960"/>
+            <a:ext cx="5212080" cy="5303520"/>
+          </a:xfrm>
+          <a:prstGeom prst="roundRect">
+            <a:avLst/>
+          </a:prstGeom>
+          <a:solidFill>
+            <a:srgbClr val="0E1626"/>
+          </a:solidFill>
+          <a:ln w="19050">
+            <a:solidFill>
+              <a:srgbClr val="3B82F6"/>
+            </a:solidFill>
+          </a:ln>
+        </p:spPr>
+        <p:style>
+          <a:lnRef idx="1">
+            <a:schemeClr val="accent1"/>
+          </a:lnRef>
+          <a:fillRef idx="3">
+            <a:schemeClr val="accent1"/>
+          </a:fillRef>
+          <a:effectRef idx="2">
+            <a:schemeClr val="accent1"/>
+          </a:effectRef>
+          <a:fontRef idx="minor">
+            <a:schemeClr val="lt1"/>
+          </a:fontRef>
+        </p:style>
+        <p:txBody>
+          <a:bodyPr rtlCol="0" anchor="ctr"/>
+          <a:lstStyle/>
+          <a:p>
+            <a:pPr algn="ctr"/>
+          </a:p>
+        </p:txBody>
+      </p:sp>
+      <p:pic>
+        <p:nvPicPr>
+          <p:cNvPr id="14" name="Picture 13" descr="01_landing_desktop_1440x900.png"/>
+          <p:cNvPicPr>
+            <a:picLocks noChangeAspect="1"/>
+          </p:cNvPicPr>
+          <p:nvPr/>
+        </p:nvPicPr>
+        <p:blipFill>
+          <a:blip r:embed="rId2"/>
+          <a:stretch>
+            <a:fillRect/>
+          </a:stretch>
+        </p:blipFill>
+        <p:spPr>
+          <a:xfrm>
+            <a:off x="6291072" y="896112"/>
+            <a:ext cx="5065776" cy="5157216"/>
+          </a:xfrm>
+          <a:prstGeom prst="rect">
+            <a:avLst/>
+          </a:prstGeom>
+        </p:spPr>
+      </p:pic>
+      <p:sp>
+        <p:nvSpPr>
+          <p:cNvPr id="15" name="TextBox 14"/>
+          <p:cNvSpPr txBox="1"/>
+          <p:nvPr/>
+        </p:nvSpPr>
+        <p:spPr>
+          <a:xfrm>
+            <a:off x="6217920" y="6181344"/>
+            <a:ext cx="5212080" cy="365760"/>
           </a:xfrm>
           <a:prstGeom prst="rect">
             <a:avLst/>
@@ -3622,44 +3723,28 @@
           <a:lstStyle/>
           <a:p>
             <a:pPr>
-              <a:spcAft>
-                <a:spcPts val="400"/>
-              </a:spcAft>
-              <a:defRPr sz="2800" b="1">
-                <a:solidFill>
-                  <a:srgbClr val="8B5CF6"/>
+              <a:defRPr sz="1000" i="1">
+                <a:solidFill>
+                  <a:srgbClr val="94A3B8"/>
                 </a:solidFill>
                 <a:latin typeface="Arial"/>
               </a:defRPr>
             </a:pPr>
             <a:r>
-              <a:t>Zero Credits</a:t>
-            </a:r>
-          </a:p>
-          <a:p>
-            <a:pPr>
-              <a:defRPr sz="1100">
-                <a:solidFill>
-                  <a:srgbClr val="94A3B8"/>
-                </a:solidFill>
-                <a:latin typeface="Arial"/>
-              </a:defRPr>
-            </a:pPr>
-            <a:r>
-              <a:t>Deterministic Offline Mock</a:t>
-            </a:r>
-          </a:p>
-        </p:txBody>
-      </p:sp>
-      <p:sp>
-        <p:nvSpPr>
-          <p:cNvPr id="13" name="TextBox 12"/>
+              <a:t>Checkout Radar Web Platform: Overview, CCPA Regulatory Context, and 1-Click Interactive Demonstrations.</a:t>
+            </a:r>
+          </a:p>
+        </p:txBody>
+      </p:sp>
+      <p:sp>
+        <p:nvSpPr>
+          <p:cNvPr id="16" name="TextBox 15"/>
           <p:cNvSpPr txBox="1"/>
           <p:nvPr/>
         </p:nvSpPr>
         <p:spPr>
           <a:xfrm>
-            <a:off x="731520" y="6309360"/>
+            <a:off x="731520" y="6355080"/>
             <a:ext cx="10698480" cy="365760"/>
           </a:xfrm>
           <a:prstGeom prst="rect">
@@ -3682,7 +3767,7 @@
               </a:defRPr>
             </a:pPr>
             <a:r>
-              <a:t>Checkout Radar · AZINHACK 2026 Submission · Slide 1 of 10</a:t>
+              <a:t>Checkout Radar · AZINHACK 2026 Presentation · Slide 1 of 10</a:t>
             </a:r>
           </a:p>
         </p:txBody>
@@ -3757,7 +3842,7 @@
         <p:spPr>
           <a:xfrm>
             <a:off x="731520" y="365760"/>
-            <a:ext cx="10698480" cy="1188720"/>
+            <a:ext cx="10698480" cy="1097280"/>
           </a:xfrm>
           <a:prstGeom prst="rect">
             <a:avLst/>
@@ -3772,7 +3857,7 @@
           <a:p>
             <a:pPr>
               <a:spcAft>
-                <a:spcPts val="400"/>
+                <a:spcPts val="300"/>
               </a:spcAft>
               <a:defRPr sz="1100" b="1">
                 <a:solidFill>
@@ -3788,9 +3873,9 @@
           <a:p>
             <a:pPr>
               <a:spcAft>
-                <a:spcPts val="400"/>
-              </a:spcAft>
-              <a:defRPr sz="2600" b="1">
+                <a:spcPts val="300"/>
+              </a:spcAft>
+              <a:defRPr sz="2500" b="1">
                 <a:solidFill>
                   <a:srgbClr val="FFFFFF"/>
                 </a:solidFill>
@@ -3803,7 +3888,7 @@
           </a:p>
           <a:p>
             <a:pPr>
-              <a:defRPr sz="1300">
+              <a:defRPr sz="1200">
                 <a:solidFill>
                   <a:srgbClr val="94A3B8"/>
                 </a:solidFill>
@@ -3869,8 +3954,8 @@
         </p:nvSpPr>
         <p:spPr>
           <a:xfrm>
-            <a:off x="960120" y="1874520"/>
-            <a:ext cx="2926080" cy="3931920"/>
+            <a:off x="914400" y="1828800"/>
+            <a:ext cx="3017520" cy="4023360"/>
           </a:xfrm>
           <a:prstGeom prst="rect">
             <a:avLst/>
@@ -3885,45 +3970,42 @@
           <a:p>
             <a:pPr>
               <a:spcAft>
-                <a:spcPts val="600"/>
-              </a:spcAft>
-              <a:defRPr sz="1300" b="1">
+                <a:spcPts val="400"/>
+              </a:spcAft>
+              <a:defRPr sz="1100" b="1">
                 <a:solidFill>
                   <a:srgbClr val="38BDF8"/>
                 </a:solidFill>
-                <a:latin typeface="Arial"/>
-              </a:defRPr>
-            </a:pPr>
-            <a:r>
-              <a:t>Phase 1: Real-Time Consumer Extension</a:t>
-            </a:r>
-          </a:p>
-          <a:p>
-            <a:pPr>
-              <a:spcAft>
-                <a:spcPts val="1400"/>
-              </a:spcAft>
-              <a:defRPr sz="1800" b="1">
+              </a:defRPr>
+            </a:pPr>
+            <a:r>
+              <a:t>PHASE 1 · NEAR-TERM</a:t>
+            </a:r>
+          </a:p>
+          <a:p>
+            <a:pPr>
+              <a:spcAft>
+                <a:spcPts val="1200"/>
+              </a:spcAft>
+              <a:defRPr sz="1600" b="1">
                 <a:solidFill>
                   <a:srgbClr val="FFFFFF"/>
                 </a:solidFill>
-                <a:latin typeface="Arial"/>
-              </a:defRPr>
-            </a:pPr>
-            <a:r>
-              <a:t>Live Browser Co-Pilot</a:t>
-            </a:r>
-          </a:p>
-          <a:p>
-            <a:pPr>
-              <a:spcAft>
-                <a:spcPts val="1000"/>
-              </a:spcAft>
-              <a:defRPr sz="1200">
+              </a:defRPr>
+            </a:pPr>
+            <a:r>
+              <a:t>Live Consumer Browser Extension</a:t>
+            </a:r>
+          </a:p>
+          <a:p>
+            <a:pPr>
+              <a:spcAft>
+                <a:spcPts val="800"/>
+              </a:spcAft>
+              <a:defRPr sz="1100">
                 <a:solidFill>
                   <a:srgbClr val="CBD5E1"/>
                 </a:solidFill>
-                <a:latin typeface="Arial"/>
               </a:defRPr>
             </a:pPr>
             <a:r>
@@ -3933,13 +4015,12 @@
           <a:p>
             <a:pPr>
               <a:spcAft>
-                <a:spcPts val="1000"/>
-              </a:spcAft>
-              <a:defRPr sz="1200">
+                <a:spcPts val="800"/>
+              </a:spcAft>
+              <a:defRPr sz="1100">
                 <a:solidFill>
                   <a:srgbClr val="CBD5E1"/>
                 </a:solidFill>
-                <a:latin typeface="Arial"/>
               </a:defRPr>
             </a:pPr>
             <a:r>
@@ -3949,13 +4030,12 @@
           <a:p>
             <a:pPr>
               <a:spcAft>
-                <a:spcPts val="1000"/>
-              </a:spcAft>
-              <a:defRPr sz="1200">
+                <a:spcPts val="800"/>
+              </a:spcAft>
+              <a:defRPr sz="1100">
                 <a:solidFill>
                   <a:srgbClr val="CBD5E1"/>
                 </a:solidFill>
-                <a:latin typeface="Arial"/>
               </a:defRPr>
             </a:pPr>
             <a:r>
@@ -4017,8 +4097,8 @@
         </p:nvSpPr>
         <p:spPr>
           <a:xfrm>
-            <a:off x="4617720" y="1874520"/>
-            <a:ext cx="2926080" cy="3931920"/>
+            <a:off x="4572000" y="1828800"/>
+            <a:ext cx="3017520" cy="4023360"/>
           </a:xfrm>
           <a:prstGeom prst="rect">
             <a:avLst/>
@@ -4033,61 +4113,57 @@
           <a:p>
             <a:pPr>
               <a:spcAft>
-                <a:spcPts val="600"/>
-              </a:spcAft>
-              <a:defRPr sz="1300" b="1">
+                <a:spcPts val="400"/>
+              </a:spcAft>
+              <a:defRPr sz="1100" b="1">
                 <a:solidFill>
                   <a:srgbClr val="3B82F6"/>
                 </a:solidFill>
-                <a:latin typeface="Arial"/>
-              </a:defRPr>
-            </a:pPr>
-            <a:r>
-              <a:t>Phase 2: National Consumer Helpline Integration</a:t>
-            </a:r>
-          </a:p>
-          <a:p>
-            <a:pPr>
-              <a:spcAft>
-                <a:spcPts val="1400"/>
-              </a:spcAft>
-              <a:defRPr sz="1800" b="1">
+              </a:defRPr>
+            </a:pPr>
+            <a:r>
+              <a:t>PHASE 2 · MID-TERM</a:t>
+            </a:r>
+          </a:p>
+          <a:p>
+            <a:pPr>
+              <a:spcAft>
+                <a:spcPts val="1200"/>
+              </a:spcAft>
+              <a:defRPr sz="1600" b="1">
                 <a:solidFill>
                   <a:srgbClr val="FFFFFF"/>
                 </a:solidFill>
-                <a:latin typeface="Arial"/>
-              </a:defRPr>
-            </a:pPr>
-            <a:r>
-              <a:t>Direct Regulatory API Pipe</a:t>
-            </a:r>
-          </a:p>
-          <a:p>
-            <a:pPr>
-              <a:spcAft>
-                <a:spcPts val="1000"/>
-              </a:spcAft>
-              <a:defRPr sz="1200">
+              </a:defRPr>
+            </a:pPr>
+            <a:r>
+              <a:t>Direct NCH API Integration</a:t>
+            </a:r>
+          </a:p>
+          <a:p>
+            <a:pPr>
+              <a:spcAft>
+                <a:spcPts val="800"/>
+              </a:spcAft>
+              <a:defRPr sz="1100">
                 <a:solidFill>
                   <a:srgbClr val="CBD5E1"/>
                 </a:solidFill>
-                <a:latin typeface="Arial"/>
-              </a:defRPr>
-            </a:pPr>
-            <a:r>
-              <a:t>•  Direct integration with NCH (National Consumer Helpline) and e-Daakhil consumer court APIs.</a:t>
-            </a:r>
-          </a:p>
-          <a:p>
-            <a:pPr>
-              <a:spcAft>
-                <a:spcPts val="1000"/>
-              </a:spcAft>
-              <a:defRPr sz="1200">
+              </a:defRPr>
+            </a:pPr>
+            <a:r>
+              <a:t>•  Direct integration with National Consumer Helpline and e-Daakhil consumer court APIs.</a:t>
+            </a:r>
+          </a:p>
+          <a:p>
+            <a:pPr>
+              <a:spcAft>
+                <a:spcPts val="800"/>
+              </a:spcAft>
+              <a:defRPr sz="1100">
                 <a:solidFill>
                   <a:srgbClr val="CBD5E1"/>
                 </a:solidFill>
-                <a:latin typeface="Arial"/>
               </a:defRPr>
             </a:pPr>
             <a:r>
@@ -4097,13 +4173,12 @@
           <a:p>
             <a:pPr>
               <a:spcAft>
-                <a:spcPts val="1000"/>
-              </a:spcAft>
-              <a:defRPr sz="1200">
+                <a:spcPts val="800"/>
+              </a:spcAft>
+              <a:defRPr sz="1100">
                 <a:solidFill>
                   <a:srgbClr val="CBD5E1"/>
                 </a:solidFill>
-                <a:latin typeface="Arial"/>
               </a:defRPr>
             </a:pPr>
             <a:r>
@@ -4165,8 +4240,8 @@
         </p:nvSpPr>
         <p:spPr>
           <a:xfrm>
-            <a:off x="8275320" y="1874520"/>
-            <a:ext cx="2926080" cy="3931920"/>
+            <a:off x="8229600" y="1828800"/>
+            <a:ext cx="3017520" cy="4023360"/>
           </a:xfrm>
           <a:prstGeom prst="rect">
             <a:avLst/>
@@ -4181,45 +4256,42 @@
           <a:p>
             <a:pPr>
               <a:spcAft>
-                <a:spcPts val="600"/>
-              </a:spcAft>
-              <a:defRPr sz="1300" b="1">
+                <a:spcPts val="400"/>
+              </a:spcAft>
+              <a:defRPr sz="1100" b="1">
                 <a:solidFill>
                   <a:srgbClr val="8B5CF6"/>
                 </a:solidFill>
-                <a:latin typeface="Arial"/>
-              </a:defRPr>
-            </a:pPr>
-            <a:r>
-              <a:t>Phase 3: Cross-Border Multi-Region Audits</a:t>
-            </a:r>
-          </a:p>
-          <a:p>
-            <a:pPr>
-              <a:spcAft>
-                <a:spcPts val="1400"/>
-              </a:spcAft>
-              <a:defRPr sz="1800" b="1">
+              </a:defRPr>
+            </a:pPr>
+            <a:r>
+              <a:t>PHASE 3 · LONG-TERM</a:t>
+            </a:r>
+          </a:p>
+          <a:p>
+            <a:pPr>
+              <a:spcAft>
+                <a:spcPts val="1200"/>
+              </a:spcAft>
+              <a:defRPr sz="1600" b="1">
                 <a:solidFill>
                   <a:srgbClr val="FFFFFF"/>
                 </a:solidFill>
-                <a:latin typeface="Arial"/>
-              </a:defRPr>
-            </a:pPr>
-            <a:r>
-              <a:t>Global E-Commerce Expansion</a:t>
-            </a:r>
-          </a:p>
-          <a:p>
-            <a:pPr>
-              <a:spcAft>
-                <a:spcPts val="1000"/>
-              </a:spcAft>
-              <a:defRPr sz="1200">
+              </a:defRPr>
+            </a:pPr>
+            <a:r>
+              <a:t>Cross-Border 7-Nation Audits</a:t>
+            </a:r>
+          </a:p>
+          <a:p>
+            <a:pPr>
+              <a:spcAft>
+                <a:spcPts val="800"/>
+              </a:spcAft>
+              <a:defRPr sz="1100">
                 <a:solidFill>
                   <a:srgbClr val="CBD5E1"/>
                 </a:solidFill>
-                <a:latin typeface="Arial"/>
               </a:defRPr>
             </a:pPr>
             <a:r>
@@ -4229,13 +4301,12 @@
           <a:p>
             <a:pPr>
               <a:spcAft>
-                <a:spcPts val="1000"/>
-              </a:spcAft>
-              <a:defRPr sz="1200">
+                <a:spcPts val="800"/>
+              </a:spcAft>
+              <a:defRPr sz="1100">
                 <a:solidFill>
                   <a:srgbClr val="CBD5E1"/>
                 </a:solidFill>
-                <a:latin typeface="Arial"/>
               </a:defRPr>
             </a:pPr>
             <a:r>
@@ -4245,17 +4316,16 @@
           <a:p>
             <a:pPr>
               <a:spcAft>
-                <a:spcPts val="1000"/>
-              </a:spcAft>
-              <a:defRPr sz="1200">
+                <a:spcPts val="800"/>
+              </a:spcAft>
+              <a:defRPr sz="1100">
                 <a:solidFill>
                   <a:srgbClr val="CBD5E1"/>
                 </a:solidFill>
-                <a:latin typeface="Arial"/>
-              </a:defRPr>
-            </a:pPr>
-            <a:r>
-              <a:t>•  Compliance engine mapped to EU Digital Services Act (DSA) and US FTC Dark Pattern guidelines.</a:t>
+              </a:defRPr>
+            </a:pPr>
+            <a:r>
+              <a:t>•  Compliance engine mapped to EU DSA and US FTC Dark Pattern guidelines.</a:t>
             </a:r>
           </a:p>
         </p:txBody>
@@ -4268,7 +4338,7 @@
         </p:nvSpPr>
         <p:spPr>
           <a:xfrm>
-            <a:off x="731520" y="6309360"/>
+            <a:off x="731520" y="6355080"/>
             <a:ext cx="10698480" cy="365760"/>
           </a:xfrm>
           <a:prstGeom prst="rect">
@@ -4291,7 +4361,7 @@
               </a:defRPr>
             </a:pPr>
             <a:r>
-              <a:t>Checkout Radar · AZINHACK 2026 Submission · Slide 10 of 10</a:t>
+              <a:t>Checkout Radar · AZINHACK 2026 Presentation · Slide 10 of 10</a:t>
             </a:r>
           </a:p>
         </p:txBody>
@@ -4366,7 +4436,7 @@
         <p:spPr>
           <a:xfrm>
             <a:off x="731520" y="365760"/>
-            <a:ext cx="10698480" cy="1188720"/>
+            <a:ext cx="10698480" cy="1097280"/>
           </a:xfrm>
           <a:prstGeom prst="rect">
             <a:avLst/>
@@ -4381,7 +4451,7 @@
           <a:p>
             <a:pPr>
               <a:spcAft>
-                <a:spcPts val="400"/>
+                <a:spcPts val="300"/>
               </a:spcAft>
               <a:defRPr sz="1100" b="1">
                 <a:solidFill>
@@ -4397,9 +4467,9 @@
           <a:p>
             <a:pPr>
               <a:spcAft>
-                <a:spcPts val="400"/>
-              </a:spcAft>
-              <a:defRPr sz="2600" b="1">
+                <a:spcPts val="300"/>
+              </a:spcAft>
+              <a:defRPr sz="2500" b="1">
                 <a:solidFill>
                   <a:srgbClr val="FFFFFF"/>
                 </a:solidFill>
@@ -4412,7 +4482,7 @@
           </a:p>
           <a:p>
             <a:pPr>
-              <a:defRPr sz="1300">
+              <a:defRPr sz="1200">
                 <a:solidFill>
                   <a:srgbClr val="94A3B8"/>
                 </a:solidFill>
@@ -4420,7 +4490,7 @@
               </a:defRPr>
             </a:pPr>
             <a:r>
-              <a:t>Indian consumers face systematic late-stage fee disclosure without any tooling for admissible legal proof.</a:t>
+              <a:t>Consumers face systemic late-stage fee disclosure without any tooling for admissible legal proof.</a:t>
             </a:r>
           </a:p>
         </p:txBody>
@@ -4434,7 +4504,7 @@
         <p:spPr>
           <a:xfrm>
             <a:off x="731520" y="1645920"/>
-            <a:ext cx="3383280" cy="4389120"/>
+            <a:ext cx="5120640" cy="1371600"/>
           </a:xfrm>
           <a:prstGeom prst="roundRect">
             <a:avLst/>
@@ -4478,8 +4548,8 @@
         </p:nvSpPr>
         <p:spPr>
           <a:xfrm>
-            <a:off x="960120" y="1874520"/>
-            <a:ext cx="2926080" cy="3931920"/>
+            <a:off x="914400" y="1755648"/>
+            <a:ext cx="4754880" cy="1152144"/>
           </a:xfrm>
           <a:prstGeom prst="rect">
             <a:avLst/>
@@ -4494,29 +4564,27 @@
           <a:p>
             <a:pPr>
               <a:spcAft>
-                <a:spcPts val="600"/>
-              </a:spcAft>
-              <a:defRPr sz="1300" b="1">
+                <a:spcPts val="200"/>
+              </a:spcAft>
+              <a:defRPr sz="1000" b="1">
                 <a:solidFill>
                   <a:srgbClr val="EF4444"/>
                 </a:solidFill>
-                <a:latin typeface="Arial"/>
-              </a:defRPr>
-            </a:pPr>
-            <a:r>
-              <a:t>💸 Late-Stage Fee Inflation</a:t>
-            </a:r>
-          </a:p>
-          <a:p>
-            <a:pPr>
-              <a:spcAft>
-                <a:spcPts val="1400"/>
-              </a:spcAft>
-              <a:defRPr sz="1800" b="1">
+              </a:defRPr>
+            </a:pPr>
+            <a:r>
+              <a:t>💸 LATE-STAGE INFLATION</a:t>
+            </a:r>
+          </a:p>
+          <a:p>
+            <a:pPr>
+              <a:spcAft>
+                <a:spcPts val="400"/>
+              </a:spcAft>
+              <a:defRPr sz="1400" b="1">
                 <a:solidFill>
                   <a:srgbClr val="FFFFFF"/>
                 </a:solidFill>
-                <a:latin typeface="Arial"/>
               </a:defRPr>
             </a:pPr>
             <a:r>
@@ -4525,50 +4593,14 @@
           </a:p>
           <a:p>
             <a:pPr>
-              <a:spcAft>
-                <a:spcPts val="1000"/>
-              </a:spcAft>
-              <a:defRPr sz="1200">
+              <a:defRPr sz="1100">
                 <a:solidFill>
                   <a:srgbClr val="CBD5E1"/>
                 </a:solidFill>
-                <a:latin typeface="Arial"/>
-              </a:defRPr>
-            </a:pPr>
-            <a:r>
-              <a:t>•  Surge fees, handling charges, packaging levies, and convenience fees appear only on the final payment screen.</a:t>
-            </a:r>
-          </a:p>
-          <a:p>
-            <a:pPr>
-              <a:spcAft>
-                <a:spcPts val="1000"/>
-              </a:spcAft>
-              <a:defRPr sz="1200">
-                <a:solidFill>
-                  <a:srgbClr val="CBD5E1"/>
-                </a:solidFill>
-                <a:latin typeface="Arial"/>
-              </a:defRPr>
-            </a:pPr>
-            <a:r>
-              <a:t>•  Consumers invest 10–15 minutes navigating products and entering addresses before the true payable price is revealed.</a:t>
-            </a:r>
-          </a:p>
-          <a:p>
-            <a:pPr>
-              <a:spcAft>
-                <a:spcPts val="1000"/>
-              </a:spcAft>
-              <a:defRPr sz="1200">
-                <a:solidFill>
-                  <a:srgbClr val="CBD5E1"/>
-                </a:solidFill>
-                <a:latin typeface="Arial"/>
-              </a:defRPr>
-            </a:pPr>
-            <a:r>
-              <a:t>•  Violates Section 18 of the Consumer Protection Act, 2019.</a:t>
+              </a:defRPr>
+            </a:pPr>
+            <a:r>
+              <a:t>Surge fees, handling charges, and packaging costs appear only on the final payment screen after 15 minutes of checkout navigation.</a:t>
             </a:r>
           </a:p>
         </p:txBody>
@@ -4581,8 +4613,8 @@
         </p:nvSpPr>
         <p:spPr>
           <a:xfrm>
-            <a:off x="4389120" y="1645920"/>
-            <a:ext cx="3383280" cy="4389120"/>
+            <a:off x="731520" y="3154680"/>
+            <a:ext cx="5120640" cy="1371600"/>
           </a:xfrm>
           <a:prstGeom prst="roundRect">
             <a:avLst/>
@@ -4626,8 +4658,8 @@
         </p:nvSpPr>
         <p:spPr>
           <a:xfrm>
-            <a:off x="4617720" y="1874520"/>
-            <a:ext cx="2926080" cy="3931920"/>
+            <a:off x="914400" y="3264408"/>
+            <a:ext cx="4754880" cy="1152144"/>
           </a:xfrm>
           <a:prstGeom prst="rect">
             <a:avLst/>
@@ -4642,97 +4674,43 @@
           <a:p>
             <a:pPr>
               <a:spcAft>
-                <a:spcPts val="600"/>
-              </a:spcAft>
-              <a:defRPr sz="1300" b="1">
+                <a:spcPts val="200"/>
+              </a:spcAft>
+              <a:defRPr sz="1000" b="1">
                 <a:solidFill>
                   <a:srgbClr val="F59E0B"/>
                 </a:solidFill>
-                <a:latin typeface="Arial"/>
-              </a:defRPr>
-            </a:pPr>
-            <a:r>
-              <a:t>⚖️ Regulatory Mandate</a:t>
-            </a:r>
-          </a:p>
-          <a:p>
-            <a:pPr>
-              <a:spcAft>
-                <a:spcPts val="1400"/>
-              </a:spcAft>
-              <a:defRPr sz="1800" b="1">
+              </a:defRPr>
+            </a:pPr>
+            <a:r>
+              <a:t>⚖️ STATUTORY MANDATE</a:t>
+            </a:r>
+          </a:p>
+          <a:p>
+            <a:pPr>
+              <a:spcAft>
+                <a:spcPts val="400"/>
+              </a:spcAft>
+              <a:defRPr sz="1400" b="1">
                 <a:solidFill>
                   <a:srgbClr val="FFFFFF"/>
                 </a:solidFill>
-                <a:latin typeface="Arial"/>
-              </a:defRPr>
-            </a:pPr>
-            <a:r>
-              <a:t>CCPA November 2023 Guidelines</a:t>
-            </a:r>
-          </a:p>
-          <a:p>
-            <a:pPr>
-              <a:spcAft>
-                <a:spcPts val="1000"/>
-              </a:spcAft>
-              <a:defRPr sz="1200">
+              </a:defRPr>
+            </a:pPr>
+            <a:r>
+              <a:t>CCPA 2023 Guidelines</a:t>
+            </a:r>
+          </a:p>
+          <a:p>
+            <a:pPr>
+              <a:defRPr sz="1100">
                 <a:solidFill>
                   <a:srgbClr val="CBD5E1"/>
                 </a:solidFill>
-                <a:latin typeface="Arial"/>
-              </a:defRPr>
-            </a:pPr>
-            <a:r>
-              <a:t>•  CCPA officially notified 13 prohibited dark patterns on 30 Nov 2023.</a:t>
-            </a:r>
-          </a:p>
-          <a:p>
-            <a:pPr>
-              <a:spcAft>
-                <a:spcPts val="1000"/>
-              </a:spcAft>
-              <a:defRPr sz="1200">
-                <a:solidFill>
-                  <a:srgbClr val="CBD5E1"/>
-                </a:solidFill>
-                <a:latin typeface="Arial"/>
-              </a:defRPr>
-            </a:pPr>
-            <a:r>
-              <a:t>•  Annex 1.8 strictly bans Drip Pricing (concealing mandatory costs).</a:t>
-            </a:r>
-          </a:p>
-          <a:p>
-            <a:pPr>
-              <a:spcAft>
-                <a:spcPts val="1000"/>
-              </a:spcAft>
-              <a:defRPr sz="1200">
-                <a:solidFill>
-                  <a:srgbClr val="CBD5E1"/>
-                </a:solidFill>
-                <a:latin typeface="Arial"/>
-              </a:defRPr>
-            </a:pPr>
-            <a:r>
-              <a:t>•  Annex 1.2 bans Basket Sneaking (pre-ticked add-ons).</a:t>
-            </a:r>
-          </a:p>
-          <a:p>
-            <a:pPr>
-              <a:spcAft>
-                <a:spcPts val="1000"/>
-              </a:spcAft>
-              <a:defRPr sz="1200">
-                <a:solidFill>
-                  <a:srgbClr val="CBD5E1"/>
-                </a:solidFill>
-                <a:latin typeface="Arial"/>
-              </a:defRPr>
-            </a:pPr>
-            <a:r>
-              <a:t>•  Annex 1.1 bans False Urgency (falsely implying urgency or resetting timers).</a:t>
+              </a:defRPr>
+            </a:pPr>
+            <a:r>
+              <a:t>Notified on 30 Nov 2023 under Consumer Protection Act 2019: Annex 1.8 strictly bans Drip Pricing; Annex 1.2 bans Basket Sneaking.</a:t>
             </a:r>
           </a:p>
         </p:txBody>
@@ -4745,8 +4723,8 @@
         </p:nvSpPr>
         <p:spPr>
           <a:xfrm>
-            <a:off x="8046720" y="1645920"/>
-            <a:ext cx="3383280" cy="4389120"/>
+            <a:off x="731520" y="4663440"/>
+            <a:ext cx="5120640" cy="1371600"/>
           </a:xfrm>
           <a:prstGeom prst="roundRect">
             <a:avLst/>
@@ -4790,8 +4768,8 @@
         </p:nvSpPr>
         <p:spPr>
           <a:xfrm>
-            <a:off x="8275320" y="1874520"/>
-            <a:ext cx="2926080" cy="3931920"/>
+            <a:off x="914400" y="4773168"/>
+            <a:ext cx="4754880" cy="1152144"/>
           </a:xfrm>
           <a:prstGeom prst="rect">
             <a:avLst/>
@@ -4806,94 +4784,161 @@
           <a:p>
             <a:pPr>
               <a:spcAft>
-                <a:spcPts val="600"/>
-              </a:spcAft>
-              <a:defRPr sz="1300" b="1">
+                <a:spcPts val="200"/>
+              </a:spcAft>
+              <a:defRPr sz="1000" b="1">
                 <a:solidFill>
                   <a:srgbClr val="3B82F6"/>
                 </a:solidFill>
+              </a:defRPr>
+            </a:pPr>
+            <a:r>
+              <a:t>🔍 THE EVIDENCE GAP</a:t>
+            </a:r>
+          </a:p>
+          <a:p>
+            <a:pPr>
+              <a:spcAft>
+                <a:spcPts val="400"/>
+              </a:spcAft>
+              <a:defRPr sz="1400" b="1">
+                <a:solidFill>
+                  <a:srgbClr val="FFFFFF"/>
+                </a:solidFill>
+              </a:defRPr>
+            </a:pPr>
+            <a:r>
+              <a:t>Lack of Empirical Outside-In Tooling</a:t>
+            </a:r>
+          </a:p>
+          <a:p>
+            <a:pPr>
+              <a:defRPr sz="1100">
+                <a:solidFill>
+                  <a:srgbClr val="CBD5E1"/>
+                </a:solidFill>
+              </a:defRPr>
+            </a:pPr>
+            <a:r>
+              <a:t>Existing compliance tools serve platform teams. Consumers, researchers, and journalists cannot capture legally admissible, reproducible proof.</a:t>
+            </a:r>
+          </a:p>
+        </p:txBody>
+      </p:sp>
+      <p:sp>
+        <p:nvSpPr>
+          <p:cNvPr id="10" name="Rounded Rectangle 9"/>
+          <p:cNvSpPr/>
+          <p:nvPr/>
+        </p:nvSpPr>
+        <p:spPr>
+          <a:xfrm>
+            <a:off x="6217920" y="1645920"/>
+            <a:ext cx="5212080" cy="4206240"/>
+          </a:xfrm>
+          <a:prstGeom prst="roundRect">
+            <a:avLst/>
+          </a:prstGeom>
+          <a:solidFill>
+            <a:srgbClr val="0E1626"/>
+          </a:solidFill>
+          <a:ln w="19050">
+            <a:solidFill>
+              <a:srgbClr val="3B82F6"/>
+            </a:solidFill>
+          </a:ln>
+        </p:spPr>
+        <p:style>
+          <a:lnRef idx="1">
+            <a:schemeClr val="accent1"/>
+          </a:lnRef>
+          <a:fillRef idx="3">
+            <a:schemeClr val="accent1"/>
+          </a:fillRef>
+          <a:effectRef idx="2">
+            <a:schemeClr val="accent1"/>
+          </a:effectRef>
+          <a:fontRef idx="minor">
+            <a:schemeClr val="lt1"/>
+          </a:fontRef>
+        </p:style>
+        <p:txBody>
+          <a:bodyPr rtlCol="0" anchor="ctr"/>
+          <a:lstStyle/>
+          <a:p>
+            <a:pPr algn="ctr"/>
+          </a:p>
+        </p:txBody>
+      </p:sp>
+      <p:pic>
+        <p:nvPicPr>
+          <p:cNvPr id="11" name="Picture 10" descr="03_indicators_detected_viewport_1440x900.png"/>
+          <p:cNvPicPr>
+            <a:picLocks noChangeAspect="1"/>
+          </p:cNvPicPr>
+          <p:nvPr/>
+        </p:nvPicPr>
+        <p:blipFill>
+          <a:blip r:embed="rId2"/>
+          <a:stretch>
+            <a:fillRect/>
+          </a:stretch>
+        </p:blipFill>
+        <p:spPr>
+          <a:xfrm>
+            <a:off x="6291072" y="1719072"/>
+            <a:ext cx="5065776" cy="4059936"/>
+          </a:xfrm>
+          <a:prstGeom prst="rect">
+            <a:avLst/>
+          </a:prstGeom>
+        </p:spPr>
+      </p:pic>
+      <p:sp>
+        <p:nvSpPr>
+          <p:cNvPr id="12" name="TextBox 11"/>
+          <p:cNvSpPr txBox="1"/>
+          <p:nvPr/>
+        </p:nvSpPr>
+        <p:spPr>
+          <a:xfrm>
+            <a:off x="6217920" y="5907024"/>
+            <a:ext cx="5212080" cy="365760"/>
+          </a:xfrm>
+          <a:prstGeom prst="rect">
+            <a:avLst/>
+          </a:prstGeom>
+          <a:noFill/>
+        </p:spPr>
+        <p:txBody>
+          <a:bodyPr wrap="square" tIns="0" lIns="0">
+            <a:spAutoFit/>
+          </a:bodyPr>
+          <a:lstStyle/>
+          <a:p>
+            <a:pPr>
+              <a:defRPr sz="1000" i="1">
+                <a:solidFill>
+                  <a:srgbClr val="94A3B8"/>
+                </a:solidFill>
                 <a:latin typeface="Arial"/>
               </a:defRPr>
             </a:pPr>
             <a:r>
-              <a:t>🔍 The Evidence Bottleneck</a:t>
-            </a:r>
-          </a:p>
-          <a:p>
-            <a:pPr>
-              <a:spcAft>
-                <a:spcPts val="1400"/>
-              </a:spcAft>
-              <a:defRPr sz="1800" b="1">
-                <a:solidFill>
-                  <a:srgbClr val="FFFFFF"/>
-                </a:solidFill>
-                <a:latin typeface="Arial"/>
-              </a:defRPr>
-            </a:pPr>
-            <a:r>
-              <a:t>Lack of Empirical Tooling</a:t>
-            </a:r>
-          </a:p>
-          <a:p>
-            <a:pPr>
-              <a:spcAft>
-                <a:spcPts val="1000"/>
-              </a:spcAft>
-              <a:defRPr sz="1200">
-                <a:solidFill>
-                  <a:srgbClr val="CBD5E1"/>
-                </a:solidFill>
-                <a:latin typeface="Arial"/>
-              </a:defRPr>
-            </a:pPr>
-            <a:r>
-              <a:t>•  Existing audit tools cater exclusively to internal platform teams.</a:t>
-            </a:r>
-          </a:p>
-          <a:p>
-            <a:pPr>
-              <a:spcAft>
-                <a:spcPts val="1000"/>
-              </a:spcAft>
-              <a:defRPr sz="1200">
-                <a:solidFill>
-                  <a:srgbClr val="CBD5E1"/>
-                </a:solidFill>
-                <a:latin typeface="Arial"/>
-              </a:defRPr>
-            </a:pPr>
-            <a:r>
-              <a:t>•  Consumers, researchers, and journalists cannot capture legally admissible, reproducible proof.</a:t>
-            </a:r>
-          </a:p>
-          <a:p>
-            <a:pPr>
-              <a:spcAft>
-                <a:spcPts val="1000"/>
-              </a:spcAft>
-              <a:defRPr sz="1200">
-                <a:solidFill>
-                  <a:srgbClr val="CBD5E1"/>
-                </a:solidFill>
-                <a:latin typeface="Arial"/>
-              </a:defRPr>
-            </a:pPr>
-            <a:r>
-              <a:t>•  Single-page apps (SPAs) defeat static web scrapers, leaving deceptive checkouts unmonitored.</a:t>
-            </a:r>
-          </a:p>
-        </p:txBody>
-      </p:sp>
-      <p:sp>
-        <p:nvSpPr>
-          <p:cNvPr id="10" name="TextBox 9"/>
+              <a:t>Real Checkout Radar detection of a ₹5.00 Handling Fee concealed on product and cart pages, revealed only at checkout summary.</a:t>
+            </a:r>
+          </a:p>
+        </p:txBody>
+      </p:sp>
+      <p:sp>
+        <p:nvSpPr>
+          <p:cNvPr id="13" name="TextBox 12"/>
           <p:cNvSpPr txBox="1"/>
           <p:nvPr/>
         </p:nvSpPr>
         <p:spPr>
           <a:xfrm>
-            <a:off x="731520" y="6309360"/>
+            <a:off x="731520" y="6355080"/>
             <a:ext cx="10698480" cy="365760"/>
           </a:xfrm>
           <a:prstGeom prst="rect">
@@ -4916,7 +4961,7 @@
               </a:defRPr>
             </a:pPr>
             <a:r>
-              <a:t>Checkout Radar · AZINHACK 2026 Submission · Slide 2 of 10</a:t>
+              <a:t>Checkout Radar · AZINHACK 2026 Presentation · Slide 2 of 10</a:t>
             </a:r>
           </a:p>
         </p:txBody>
@@ -4991,7 +5036,7 @@
         <p:spPr>
           <a:xfrm>
             <a:off x="731520" y="365760"/>
-            <a:ext cx="10698480" cy="1188720"/>
+            <a:ext cx="10698480" cy="1097280"/>
           </a:xfrm>
           <a:prstGeom prst="rect">
             <a:avLst/>
@@ -5006,7 +5051,7 @@
           <a:p>
             <a:pPr>
               <a:spcAft>
-                <a:spcPts val="400"/>
+                <a:spcPts val="300"/>
               </a:spcAft>
               <a:defRPr sz="1100" b="1">
                 <a:solidFill>
@@ -5022,9 +5067,9 @@
           <a:p>
             <a:pPr>
               <a:spcAft>
-                <a:spcPts val="400"/>
-              </a:spcAft>
-              <a:defRPr sz="2600" b="1">
+                <a:spcPts val="300"/>
+              </a:spcAft>
+              <a:defRPr sz="2500" b="1">
                 <a:solidFill>
                   <a:srgbClr val="FFFFFF"/>
                 </a:solidFill>
@@ -5037,7 +5082,7 @@
           </a:p>
           <a:p>
             <a:pPr>
-              <a:defRPr sz="1300">
+              <a:defRPr sz="1200">
                 <a:solidFill>
                   <a:srgbClr val="94A3B8"/>
                 </a:solidFill>
@@ -5045,7 +5090,7 @@
               </a:defRPr>
             </a:pPr>
             <a:r>
-              <a:t>Turning subjective allegations into controlled, reproducible, screenshot-backed empirical proof.</a:t>
+              <a:t>Not a scraper: controlled behavioral experiments that isolate fee triggers while holding controls fixed.</a:t>
             </a:r>
           </a:p>
         </p:txBody>
@@ -5058,8 +5103,8 @@
         </p:nvSpPr>
         <p:spPr>
           <a:xfrm>
-            <a:off x="731520" y="1645920"/>
-            <a:ext cx="4572000" cy="4389120"/>
+            <a:off x="731520" y="1600200"/>
+            <a:ext cx="2514600" cy="868680"/>
           </a:xfrm>
           <a:prstGeom prst="roundRect">
             <a:avLst/>
@@ -5103,8 +5148,8 @@
         </p:nvSpPr>
         <p:spPr>
           <a:xfrm>
-            <a:off x="960120" y="1874519"/>
-            <a:ext cx="4114800" cy="3931920"/>
+            <a:off x="841248" y="1691640"/>
+            <a:ext cx="2295144" cy="685800"/>
           </a:xfrm>
           <a:prstGeom prst="rect">
             <a:avLst/>
@@ -5119,97 +5164,28 @@
           <a:p>
             <a:pPr>
               <a:spcAft>
-                <a:spcPts val="1000"/>
-              </a:spcAft>
-              <a:defRPr sz="2000" b="1">
+                <a:spcPts val="200"/>
+              </a:spcAft>
+              <a:defRPr sz="1300" b="1">
                 <a:solidFill>
                   <a:srgbClr val="38BDF8"/>
                 </a:solidFill>
-                <a:latin typeface="Arial"/>
-              </a:defRPr>
-            </a:pPr>
-            <a:r>
-              <a:t>Controlled Scientific Method</a:t>
-            </a:r>
-          </a:p>
-          <a:p>
-            <a:pPr>
-              <a:spcAft>
-                <a:spcPts val="1000"/>
-              </a:spcAft>
-              <a:defRPr sz="1200">
+              </a:defRPr>
+            </a:pPr>
+            <a:r>
+              <a:t>📍 Location</a:t>
+            </a:r>
+          </a:p>
+          <a:p>
+            <a:pPr>
+              <a:defRPr sz="1000">
                 <a:solidFill>
                   <a:srgbClr val="CBD5E1"/>
                 </a:solidFill>
-                <a:latin typeface="Arial"/>
-              </a:defRPr>
-            </a:pPr>
-            <a:r>
-              <a:t>✓  Not a scraper: Checkout Radar executes controlled behavioral experiments.</a:t>
-            </a:r>
-          </a:p>
-          <a:p>
-            <a:pPr>
-              <a:spcAft>
-                <a:spcPts val="1000"/>
-              </a:spcAft>
-              <a:defRPr sz="1200">
-                <a:solidFill>
-                  <a:srgbClr val="CBD5E1"/>
-                </a:solidFill>
-                <a:latin typeface="Arial"/>
-              </a:defRPr>
-            </a:pPr>
-            <a:r>
-              <a:t>✓  Differential Principle: Compares two runs that differ in exactly one requested dimension while holding all other controls fixed.</a:t>
-            </a:r>
-          </a:p>
-          <a:p>
-            <a:pPr>
-              <a:spcAft>
-                <a:spcPts val="1000"/>
-              </a:spcAft>
-              <a:defRPr sz="1200">
-                <a:solidFill>
-                  <a:srgbClr val="CBD5E1"/>
-                </a:solidFill>
-                <a:latin typeface="Arial"/>
-              </a:defRPr>
-            </a:pPr>
-            <a:r>
-              <a:t>✓  Integer Minor-Unit Math: Reconciles all charges in integer paise (₹0.01) to eliminate rounding errors.</a:t>
-            </a:r>
-          </a:p>
-          <a:p>
-            <a:pPr>
-              <a:spcAft>
-                <a:spcPts val="1000"/>
-              </a:spcAft>
-              <a:defRPr sz="1200">
-                <a:solidFill>
-                  <a:srgbClr val="CBD5E1"/>
-                </a:solidFill>
-                <a:latin typeface="Arial"/>
-              </a:defRPr>
-            </a:pPr>
-            <a:r>
-              <a:t>✓  The Cart Invariant: Separates Recipe Family from Cart Instance. Quantity changes do NOT trigger false price variance alarms.</a:t>
-            </a:r>
-          </a:p>
-          <a:p>
-            <a:pPr>
-              <a:spcAft>
-                <a:spcPts val="1000"/>
-              </a:spcAft>
-              <a:defRPr sz="1200">
-                <a:solidFill>
-                  <a:srgbClr val="CBD5E1"/>
-                </a:solidFill>
-                <a:latin typeface="Arial"/>
-              </a:defRPr>
-            </a:pPr>
-            <a:r>
-              <a:t>✓  Cryptographic Custody: 1280×720 viewports redacted with Pillow and hashed with SHA-256.</a:t>
+              </a:defRPr>
+            </a:pPr>
+            <a:r>
+              <a:t>Tier-1 Metro vs Tier-2/3 Pincodes</a:t>
             </a:r>
           </a:p>
         </p:txBody>
@@ -5222,8 +5198,8 @@
         </p:nvSpPr>
         <p:spPr>
           <a:xfrm>
-            <a:off x="5577840" y="1645920"/>
-            <a:ext cx="5852160" cy="960120"/>
+            <a:off x="3456432" y="1600200"/>
+            <a:ext cx="2514600" cy="868680"/>
           </a:xfrm>
           <a:prstGeom prst="roundRect">
             <a:avLst/>
@@ -5267,8 +5243,8 @@
         </p:nvSpPr>
         <p:spPr>
           <a:xfrm>
-            <a:off x="5760720" y="1755648"/>
-            <a:ext cx="5486400" cy="740664"/>
+            <a:off x="3566160" y="1691640"/>
+            <a:ext cx="2295144" cy="685800"/>
           </a:xfrm>
           <a:prstGeom prst="rect">
             <a:avLst/>
@@ -5285,28 +5261,26 @@
               <a:spcAft>
                 <a:spcPts val="200"/>
               </a:spcAft>
-              <a:defRPr sz="1400" b="1">
-                <a:solidFill>
-                  <a:srgbClr val="38BDF8"/>
-                </a:solidFill>
-                <a:latin typeface="Arial"/>
-              </a:defRPr>
-            </a:pPr>
-            <a:r>
-              <a:t>📍 Location Effect</a:t>
-            </a:r>
-          </a:p>
-          <a:p>
-            <a:pPr>
-              <a:defRPr sz="1100">
-                <a:solidFill>
-                  <a:srgbClr val="94A3B8"/>
-                </a:solidFill>
-                <a:latin typeface="Arial"/>
-              </a:defRPr>
-            </a:pPr>
-            <a:r>
-              <a:t>Tests Tier-1 Metro vs Tier-2/3 Pincodes (e.g. 110001 vs 492001)  |  Controls: Session state, cart tier, recipe family</a:t>
+              <a:defRPr sz="1300" b="1">
+                <a:solidFill>
+                  <a:srgbClr val="3B82F6"/>
+                </a:solidFill>
+              </a:defRPr>
+            </a:pPr>
+            <a:r>
+              <a:t>👤 Session</a:t>
+            </a:r>
+          </a:p>
+          <a:p>
+            <a:pPr>
+              <a:defRPr sz="1000">
+                <a:solidFill>
+                  <a:srgbClr val="CBD5E1"/>
+                </a:solidFill>
+              </a:defRPr>
+            </a:pPr>
+            <a:r>
+              <a:t>Fresh Guest vs Returning Profile</a:t>
             </a:r>
           </a:p>
         </p:txBody>
@@ -5319,8 +5293,8 @@
         </p:nvSpPr>
         <p:spPr>
           <a:xfrm>
-            <a:off x="5577840" y="2788920"/>
-            <a:ext cx="5852160" cy="960120"/>
+            <a:off x="6181344" y="1600200"/>
+            <a:ext cx="2514600" cy="868680"/>
           </a:xfrm>
           <a:prstGeom prst="roundRect">
             <a:avLst/>
@@ -5364,8 +5338,8 @@
         </p:nvSpPr>
         <p:spPr>
           <a:xfrm>
-            <a:off x="5760720" y="2898648"/>
-            <a:ext cx="5486400" cy="740664"/>
+            <a:off x="6291072" y="1691640"/>
+            <a:ext cx="2295144" cy="685800"/>
           </a:xfrm>
           <a:prstGeom prst="rect">
             <a:avLst/>
@@ -5382,28 +5356,26 @@
               <a:spcAft>
                 <a:spcPts val="200"/>
               </a:spcAft>
-              <a:defRPr sz="1400" b="1">
-                <a:solidFill>
-                  <a:srgbClr val="3B82F6"/>
-                </a:solidFill>
-                <a:latin typeface="Arial"/>
-              </a:defRPr>
-            </a:pPr>
-            <a:r>
-              <a:t>👤 Session Effect</a:t>
-            </a:r>
-          </a:p>
-          <a:p>
-            <a:pPr>
-              <a:defRPr sz="1100">
-                <a:solidFill>
-                  <a:srgbClr val="94A3B8"/>
-                </a:solidFill>
-                <a:latin typeface="Arial"/>
-              </a:defRPr>
-            </a:pPr>
-            <a:r>
-              <a:t>Tests Fresh Guest Profile vs Returning Customer Profile  |  Controls: Delivery pincode, cart tier, recipe family</a:t>
+              <a:defRPr sz="1300" b="1">
+                <a:solidFill>
+                  <a:srgbClr val="10B981"/>
+                </a:solidFill>
+              </a:defRPr>
+            </a:pPr>
+            <a:r>
+              <a:t>🛒 Cart Threshold</a:t>
+            </a:r>
+          </a:p>
+          <a:p>
+            <a:pPr>
+              <a:defRPr sz="1000">
+                <a:solidFill>
+                  <a:srgbClr val="CBD5E1"/>
+                </a:solidFill>
+              </a:defRPr>
+            </a:pPr>
+            <a:r>
+              <a:t>Above vs Below Free-Shipping Tier</a:t>
             </a:r>
           </a:p>
         </p:txBody>
@@ -5416,8 +5388,8 @@
         </p:nvSpPr>
         <p:spPr>
           <a:xfrm>
-            <a:off x="5577840" y="3931920"/>
-            <a:ext cx="5852160" cy="960120"/>
+            <a:off x="8906256" y="1600200"/>
+            <a:ext cx="2514600" cy="868680"/>
           </a:xfrm>
           <a:prstGeom prst="roundRect">
             <a:avLst/>
@@ -5461,8 +5433,8 @@
         </p:nvSpPr>
         <p:spPr>
           <a:xfrm>
-            <a:off x="5760720" y="4041648"/>
-            <a:ext cx="5486400" cy="740664"/>
+            <a:off x="9015984" y="1691640"/>
+            <a:ext cx="2295144" cy="685800"/>
           </a:xfrm>
           <a:prstGeom prst="rect">
             <a:avLst/>
@@ -5479,28 +5451,26 @@
               <a:spcAft>
                 <a:spcPts val="200"/>
               </a:spcAft>
-              <a:defRPr sz="1400" b="1">
-                <a:solidFill>
-                  <a:srgbClr val="10B981"/>
-                </a:solidFill>
-                <a:latin typeface="Arial"/>
-              </a:defRPr>
-            </a:pPr>
-            <a:r>
-              <a:t>🛒 Cart Threshold</a:t>
-            </a:r>
-          </a:p>
-          <a:p>
-            <a:pPr>
-              <a:defRPr sz="1100">
-                <a:solidFill>
-                  <a:srgbClr val="94A3B8"/>
-                </a:solidFill>
-                <a:latin typeface="Arial"/>
-              </a:defRPr>
-            </a:pPr>
-            <a:r>
-              <a:t>Tests Above Threshold (₹998) vs Below Threshold (₹499)  |  Controls: Delivery pincode, session state, unit price</a:t>
+              <a:defRPr sz="1300" b="1">
+                <a:solidFill>
+                  <a:srgbClr val="8B5CF6"/>
+                </a:solidFill>
+              </a:defRPr>
+            </a:pPr>
+            <a:r>
+              <a:t>⏱️ Temporal Drift</a:t>
+            </a:r>
+          </a:p>
+          <a:p>
+            <a:pPr>
+              <a:defRPr sz="1000">
+                <a:solidFill>
+                  <a:srgbClr val="CBD5E1"/>
+                </a:solidFill>
+              </a:defRPr>
+            </a:pPr>
+            <a:r>
+              <a:t>Time t0 vs Re-observation at t1</a:t>
             </a:r>
           </a:p>
         </p:txBody>
@@ -5513,8 +5483,8 @@
         </p:nvSpPr>
         <p:spPr>
           <a:xfrm>
-            <a:off x="5577840" y="5074920"/>
-            <a:ext cx="5852160" cy="960120"/>
+            <a:off x="731520" y="2651760"/>
+            <a:ext cx="5120640" cy="3474720"/>
           </a:xfrm>
           <a:prstGeom prst="roundRect">
             <a:avLst/>
@@ -5558,8 +5528,8 @@
         </p:nvSpPr>
         <p:spPr>
           <a:xfrm>
-            <a:off x="5760720" y="5184648"/>
-            <a:ext cx="5486400" cy="740664"/>
+            <a:off x="960120" y="2834640"/>
+            <a:ext cx="4663440" cy="3108960"/>
           </a:xfrm>
           <a:prstGeom prst="rect">
             <a:avLst/>
@@ -5574,43 +5544,194 @@
           <a:p>
             <a:pPr>
               <a:spcAft>
-                <a:spcPts val="200"/>
-              </a:spcAft>
-              <a:defRPr sz="1400" b="1">
-                <a:solidFill>
-                  <a:srgbClr val="8B5CF6"/>
+                <a:spcPts val="800"/>
+              </a:spcAft>
+              <a:defRPr sz="1800" b="1">
+                <a:solidFill>
+                  <a:srgbClr val="38BDF8"/>
+                </a:solidFill>
+              </a:defRPr>
+            </a:pPr>
+            <a:r>
+              <a:t>The Cart Invariant Principle</a:t>
+            </a:r>
+          </a:p>
+          <a:p>
+            <a:pPr>
+              <a:spcAft>
+                <a:spcPts val="600"/>
+              </a:spcAft>
+              <a:defRPr sz="1100">
+                <a:solidFill>
+                  <a:srgbClr val="CBD5E1"/>
+                </a:solidFill>
+              </a:defRPr>
+            </a:pPr>
+            <a:r>
+              <a:t>✓  Separates Recipe Family from Cart Instance: Adding items to reach free shipping moves the subtotal without changing unit prices.</a:t>
+            </a:r>
+          </a:p>
+          <a:p>
+            <a:pPr>
+              <a:spcAft>
+                <a:spcPts val="600"/>
+              </a:spcAft>
+              <a:defRPr sz="1100">
+                <a:solidFill>
+                  <a:srgbClr val="CBD5E1"/>
+                </a:solidFill>
+              </a:defRPr>
+            </a:pPr>
+            <a:r>
+              <a:t>✓  Zero False Alarms: Standard small-cart delivery rules are correctly reported as legitimate policy rules (SMALL_CART_RULE), not deceptive price discrimination.</a:t>
+            </a:r>
+          </a:p>
+          <a:p>
+            <a:pPr>
+              <a:spcAft>
+                <a:spcPts val="600"/>
+              </a:spcAft>
+              <a:defRPr sz="1100">
+                <a:solidFill>
+                  <a:srgbClr val="CBD5E1"/>
+                </a:solidFill>
+              </a:defRPr>
+            </a:pPr>
+            <a:r>
+              <a:t>✓  Integer Minor-Unit Math: Reconciles Subtotal + Charges + Taxes - Discounts == Payable in integer paise (₹0.01).</a:t>
+            </a:r>
+          </a:p>
+          <a:p>
+            <a:pPr>
+              <a:spcAft>
+                <a:spcPts val="600"/>
+              </a:spcAft>
+              <a:defRPr sz="1100">
+                <a:solidFill>
+                  <a:srgbClr val="CBD5E1"/>
+                </a:solidFill>
+              </a:defRPr>
+            </a:pPr>
+            <a:r>
+              <a:t>✓  Deterministic Diff Engine: Compares runs differing in exactly one requested dimension.</a:t>
+            </a:r>
+          </a:p>
+        </p:txBody>
+      </p:sp>
+      <p:sp>
+        <p:nvSpPr>
+          <p:cNvPr id="14" name="Rounded Rectangle 13"/>
+          <p:cNvSpPr/>
+          <p:nvPr/>
+        </p:nvSpPr>
+        <p:spPr>
+          <a:xfrm>
+            <a:off x="6217920" y="2651760"/>
+            <a:ext cx="5212080" cy="3474720"/>
+          </a:xfrm>
+          <a:prstGeom prst="roundRect">
+            <a:avLst/>
+          </a:prstGeom>
+          <a:solidFill>
+            <a:srgbClr val="0E1626"/>
+          </a:solidFill>
+          <a:ln w="19050">
+            <a:solidFill>
+              <a:srgbClr val="3B82F6"/>
+            </a:solidFill>
+          </a:ln>
+        </p:spPr>
+        <p:style>
+          <a:lnRef idx="1">
+            <a:schemeClr val="accent1"/>
+          </a:lnRef>
+          <a:fillRef idx="3">
+            <a:schemeClr val="accent1"/>
+          </a:fillRef>
+          <a:effectRef idx="2">
+            <a:schemeClr val="accent1"/>
+          </a:effectRef>
+          <a:fontRef idx="minor">
+            <a:schemeClr val="lt1"/>
+          </a:fontRef>
+        </p:style>
+        <p:txBody>
+          <a:bodyPr rtlCol="0" anchor="ctr"/>
+          <a:lstStyle/>
+          <a:p>
+            <a:pPr algn="ctr"/>
+          </a:p>
+        </p:txBody>
+      </p:sp>
+      <p:pic>
+        <p:nvPicPr>
+          <p:cNvPr id="15" name="Picture 14" descr="06_real_merchant_gallery_viewport_1440x900.png"/>
+          <p:cNvPicPr>
+            <a:picLocks noChangeAspect="1"/>
+          </p:cNvPicPr>
+          <p:nvPr/>
+        </p:nvPicPr>
+        <p:blipFill>
+          <a:blip r:embed="rId2"/>
+          <a:stretch>
+            <a:fillRect/>
+          </a:stretch>
+        </p:blipFill>
+        <p:spPr>
+          <a:xfrm>
+            <a:off x="6291072" y="2724912"/>
+            <a:ext cx="5065776" cy="3328416"/>
+          </a:xfrm>
+          <a:prstGeom prst="rect">
+            <a:avLst/>
+          </a:prstGeom>
+        </p:spPr>
+      </p:pic>
+      <p:sp>
+        <p:nvSpPr>
+          <p:cNvPr id="16" name="TextBox 15"/>
+          <p:cNvSpPr txBox="1"/>
+          <p:nvPr/>
+        </p:nvSpPr>
+        <p:spPr>
+          <a:xfrm>
+            <a:off x="6217920" y="6181344"/>
+            <a:ext cx="5212080" cy="365760"/>
+          </a:xfrm>
+          <a:prstGeom prst="rect">
+            <a:avLst/>
+          </a:prstGeom>
+          <a:noFill/>
+        </p:spPr>
+        <p:txBody>
+          <a:bodyPr wrap="square" tIns="0" lIns="0">
+            <a:spAutoFit/>
+          </a:bodyPr>
+          <a:lstStyle/>
+          <a:p>
+            <a:pPr>
+              <a:defRPr sz="1000" i="1">
+                <a:solidFill>
+                  <a:srgbClr val="94A3B8"/>
                 </a:solidFill>
                 <a:latin typeface="Arial"/>
               </a:defRPr>
             </a:pPr>
             <a:r>
-              <a:t>⏱️ Temporal Drift</a:t>
-            </a:r>
-          </a:p>
-          <a:p>
-            <a:pPr>
-              <a:defRPr sz="1100">
-                <a:solidFill>
-                  <a:srgbClr val="94A3B8"/>
-                </a:solidFill>
-                <a:latin typeface="Arial"/>
-              </a:defRPr>
-            </a:pPr>
-            <a:r>
-              <a:t>Tests Observation at t0 vs Re-observation at t1 across time  |  Controls: All factors and cart recipe held fixed</a:t>
-            </a:r>
-          </a:p>
-        </p:txBody>
-      </p:sp>
-      <p:sp>
-        <p:nvSpPr>
-          <p:cNvPr id="14" name="TextBox 13"/>
+              <a:t>3-Stage Visual Evidence Gallery: Product Page, Cart Drawer, and Checkout Summary with cryptographic SHA-256 digests.</a:t>
+            </a:r>
+          </a:p>
+        </p:txBody>
+      </p:sp>
+      <p:sp>
+        <p:nvSpPr>
+          <p:cNvPr id="17" name="TextBox 16"/>
           <p:cNvSpPr txBox="1"/>
           <p:nvPr/>
         </p:nvSpPr>
         <p:spPr>
           <a:xfrm>
-            <a:off x="731520" y="6309360"/>
+            <a:off x="731520" y="6355080"/>
             <a:ext cx="10698480" cy="365760"/>
           </a:xfrm>
           <a:prstGeom prst="rect">
@@ -5633,7 +5754,7 @@
               </a:defRPr>
             </a:pPr>
             <a:r>
-              <a:t>Checkout Radar · AZINHACK 2026 Submission · Slide 3 of 10</a:t>
+              <a:t>Checkout Radar · AZINHACK 2026 Presentation · Slide 3 of 10</a:t>
             </a:r>
           </a:p>
         </p:txBody>
@@ -5708,7 +5829,7 @@
         <p:spPr>
           <a:xfrm>
             <a:off x="731520" y="365760"/>
-            <a:ext cx="10698480" cy="1188720"/>
+            <a:ext cx="10698480" cy="1097280"/>
           </a:xfrm>
           <a:prstGeom prst="rect">
             <a:avLst/>
@@ -5723,7 +5844,7 @@
           <a:p>
             <a:pPr>
               <a:spcAft>
-                <a:spcPts val="400"/>
+                <a:spcPts val="300"/>
               </a:spcAft>
               <a:defRPr sz="1100" b="1">
                 <a:solidFill>
@@ -5739,9 +5860,9 @@
           <a:p>
             <a:pPr>
               <a:spcAft>
-                <a:spcPts val="400"/>
-              </a:spcAft>
-              <a:defRPr sz="2600" b="1">
+                <a:spcPts val="300"/>
+              </a:spcAft>
+              <a:defRPr sz="2500" b="1">
                 <a:solidFill>
                   <a:srgbClr val="FFFFFF"/>
                 </a:solidFill>
@@ -5749,12 +5870,12 @@
               </a:defRPr>
             </a:pPr>
             <a:r>
-              <a:t>Empowering Stakeholders Across the Consumer Protection Ecosystem</a:t>
-            </a:r>
-          </a:p>
-          <a:p>
-            <a:pPr>
-              <a:defRPr sz="1300">
+              <a:t>Empowering the Consumer Protection Ecosystem</a:t>
+            </a:r>
+          </a:p>
+          <a:p>
+            <a:pPr>
+              <a:defRPr sz="1200">
                 <a:solidFill>
                   <a:srgbClr val="94A3B8"/>
                 </a:solidFill>
@@ -5762,7 +5883,7 @@
               </a:defRPr>
             </a:pPr>
             <a:r>
-              <a:t>Three primary personas benefiting from automated outside-in checkout transparency.</a:t>
+              <a:t>Three key personas benefiting from automated outside-in checkout transparency.</a:t>
             </a:r>
           </a:p>
         </p:txBody>
@@ -5776,7 +5897,7 @@
         <p:spPr>
           <a:xfrm>
             <a:off x="731520" y="1645920"/>
-            <a:ext cx="3383280" cy="4389120"/>
+            <a:ext cx="5120640" cy="1371600"/>
           </a:xfrm>
           <a:prstGeom prst="roundRect">
             <a:avLst/>
@@ -5820,8 +5941,8 @@
         </p:nvSpPr>
         <p:spPr>
           <a:xfrm>
-            <a:off x="960120" y="1874520"/>
-            <a:ext cx="2926080" cy="3931920"/>
+            <a:off x="914400" y="1755648"/>
+            <a:ext cx="4754880" cy="1152144"/>
           </a:xfrm>
           <a:prstGeom prst="rect">
             <a:avLst/>
@@ -5836,97 +5957,43 @@
           <a:p>
             <a:pPr>
               <a:spcAft>
-                <a:spcPts val="600"/>
-              </a:spcAft>
-              <a:defRPr sz="1300" b="1">
+                <a:spcPts val="200"/>
+              </a:spcAft>
+              <a:defRPr sz="1000" b="1">
                 <a:solidFill>
                   <a:srgbClr val="38BDF8"/>
                 </a:solidFill>
-                <a:latin typeface="Arial"/>
-              </a:defRPr>
-            </a:pPr>
-            <a:r>
-              <a:t>Consumers &amp; Advocates</a:t>
-            </a:r>
-          </a:p>
-          <a:p>
-            <a:pPr>
-              <a:spcAft>
-                <a:spcPts val="1400"/>
-              </a:spcAft>
-              <a:defRPr sz="1800" b="1">
+              </a:defRPr>
+            </a:pPr>
+            <a:r>
+              <a:t>01 · CONSUMERS &amp; ADVOCATES</a:t>
+            </a:r>
+          </a:p>
+          <a:p>
+            <a:pPr>
+              <a:spcAft>
+                <a:spcPts val="400"/>
+              </a:spcAft>
+              <a:defRPr sz="1400" b="1">
                 <a:solidFill>
                   <a:srgbClr val="FFFFFF"/>
                 </a:solidFill>
-                <a:latin typeface="Arial"/>
-              </a:defRPr>
-            </a:pPr>
-            <a:r>
-              <a:t>Grievance Filing &amp; NCH Redressal</a:t>
-            </a:r>
-          </a:p>
-          <a:p>
-            <a:pPr>
-              <a:spcAft>
-                <a:spcPts val="1000"/>
-              </a:spcAft>
-              <a:defRPr sz="1200">
+              </a:defRPr>
+            </a:pPr>
+            <a:r>
+              <a:t>1-Click NCH Grievance Filing</a:t>
+            </a:r>
+          </a:p>
+          <a:p>
+            <a:pPr>
+              <a:defRPr sz="1100">
                 <a:solidFill>
                   <a:srgbClr val="CBD5E1"/>
                 </a:solidFill>
-                <a:latin typeface="Arial"/>
-              </a:defRPr>
-            </a:pPr>
-            <a:r>
-              <a:t>•  Generate ready-to-file National Consumer Helpline (NCH) grievance drafts.</a:t>
-            </a:r>
-          </a:p>
-          <a:p>
-            <a:pPr>
-              <a:spcAft>
-                <a:spcPts val="1000"/>
-              </a:spcAft>
-              <a:defRPr sz="1200">
-                <a:solidFill>
-                  <a:srgbClr val="CBD5E1"/>
-                </a:solidFill>
-                <a:latin typeface="Arial"/>
-              </a:defRPr>
-            </a:pPr>
-            <a:r>
-              <a:t>•  Pre-filled with merchant identity, exact fee breakdown, and statutory CCPA citations.</a:t>
-            </a:r>
-          </a:p>
-          <a:p>
-            <a:pPr>
-              <a:spcAft>
-                <a:spcPts val="1000"/>
-              </a:spcAft>
-              <a:defRPr sz="1200">
-                <a:solidFill>
-                  <a:srgbClr val="CBD5E1"/>
-                </a:solidFill>
-                <a:latin typeface="Arial"/>
-              </a:defRPr>
-            </a:pPr>
-            <a:r>
-              <a:t>•  Includes tamper-evident SHA-256 evidence links that merchants cannot dispute.</a:t>
-            </a:r>
-          </a:p>
-          <a:p>
-            <a:pPr>
-              <a:spcAft>
-                <a:spcPts val="1000"/>
-              </a:spcAft>
-              <a:defRPr sz="1200">
-                <a:solidFill>
-                  <a:srgbClr val="CBD5E1"/>
-                </a:solidFill>
-                <a:latin typeface="Arial"/>
-              </a:defRPr>
-            </a:pPr>
-            <a:r>
-              <a:t>•  Reduces complaint preparation time from 45 minutes to 30 seconds.</a:t>
+              </a:defRPr>
+            </a:pPr>
+            <a:r>
+              <a:t>Reduces National Consumer Helpline complaint preparation from 45 minutes to 30 seconds with pre-filled CCPA citations and SHA-256 evidence links.</a:t>
             </a:r>
           </a:p>
         </p:txBody>
@@ -5939,8 +6006,8 @@
         </p:nvSpPr>
         <p:spPr>
           <a:xfrm>
-            <a:off x="4389120" y="1645920"/>
-            <a:ext cx="3383280" cy="4389120"/>
+            <a:off x="731520" y="3154680"/>
+            <a:ext cx="5120640" cy="1371600"/>
           </a:xfrm>
           <a:prstGeom prst="roundRect">
             <a:avLst/>
@@ -5984,8 +6051,8 @@
         </p:nvSpPr>
         <p:spPr>
           <a:xfrm>
-            <a:off x="4617720" y="1874520"/>
-            <a:ext cx="2926080" cy="3931920"/>
+            <a:off x="914400" y="3264408"/>
+            <a:ext cx="4754880" cy="1152144"/>
           </a:xfrm>
           <a:prstGeom prst="rect">
             <a:avLst/>
@@ -6000,81 +6067,43 @@
           <a:p>
             <a:pPr>
               <a:spcAft>
-                <a:spcPts val="600"/>
-              </a:spcAft>
-              <a:defRPr sz="1300" b="1">
+                <a:spcPts val="200"/>
+              </a:spcAft>
+              <a:defRPr sz="1000" b="1">
                 <a:solidFill>
                   <a:srgbClr val="3B82F6"/>
                 </a:solidFill>
-                <a:latin typeface="Arial"/>
-              </a:defRPr>
-            </a:pPr>
-            <a:r>
-              <a:t>Investigative Media</a:t>
-            </a:r>
-          </a:p>
-          <a:p>
-            <a:pPr>
-              <a:spcAft>
-                <a:spcPts val="1400"/>
-              </a:spcAft>
-              <a:defRPr sz="1800" b="1">
+              </a:defRPr>
+            </a:pPr>
+            <a:r>
+              <a:t>02 · INVESTIGATIVE JOURNALISTS</a:t>
+            </a:r>
+          </a:p>
+          <a:p>
+            <a:pPr>
+              <a:spcAft>
+                <a:spcPts val="400"/>
+              </a:spcAft>
+              <a:defRPr sz="1400" b="1">
                 <a:solidFill>
                   <a:srgbClr val="FFFFFF"/>
                 </a:solidFill>
-                <a:latin typeface="Arial"/>
-              </a:defRPr>
-            </a:pPr>
-            <a:r>
-              <a:t>Empirical Exposés &amp; Research</a:t>
-            </a:r>
-          </a:p>
-          <a:p>
-            <a:pPr>
-              <a:spcAft>
-                <a:spcPts val="1000"/>
-              </a:spcAft>
-              <a:defRPr sz="1200">
+              </a:defRPr>
+            </a:pPr>
+            <a:r>
+              <a:t>Empirical Exposés &amp; Datasets</a:t>
+            </a:r>
+          </a:p>
+          <a:p>
+            <a:pPr>
+              <a:defRPr sz="1100">
                 <a:solidFill>
                   <a:srgbClr val="CBD5E1"/>
                 </a:solidFill>
-                <a:latin typeface="Arial"/>
-              </a:defRPr>
-            </a:pPr>
-            <a:r>
-              <a:t>•  Empirical, reproducible datasets on fee inflation, surge charges, and geographic discrimination.</a:t>
-            </a:r>
-          </a:p>
-          <a:p>
-            <a:pPr>
-              <a:spcAft>
-                <a:spcPts val="1000"/>
-              </a:spcAft>
-              <a:defRPr sz="1200">
-                <a:solidFill>
-                  <a:srgbClr val="CBD5E1"/>
-                </a:solidFill>
-                <a:latin typeface="Arial"/>
-              </a:defRPr>
-            </a:pPr>
-            <a:r>
-              <a:t>•  Export self-contained, offline HTML dossiers complete with high-res viewports.</a:t>
-            </a:r>
-          </a:p>
-          <a:p>
-            <a:pPr>
-              <a:spcAft>
-                <a:spcPts val="1000"/>
-              </a:spcAft>
-              <a:defRPr sz="1200">
-                <a:solidFill>
-                  <a:srgbClr val="CBD5E1"/>
-                </a:solidFill>
-                <a:latin typeface="Arial"/>
-              </a:defRPr>
-            </a:pPr>
-            <a:r>
-              <a:t>•  Enables data-driven investigative reporting on quick-commerce and retail cart practices.</a:t>
+              </a:defRPr>
+            </a:pPr>
+            <a:r>
+              <a:t>Provides reproducible, exportable HTML dossiers backed by timestamped logs to expose predatory pricing, surge fees, and geographic discrimination.</a:t>
             </a:r>
           </a:p>
         </p:txBody>
@@ -6087,8 +6116,8 @@
         </p:nvSpPr>
         <p:spPr>
           <a:xfrm>
-            <a:off x="8046720" y="1645920"/>
-            <a:ext cx="3383280" cy="4389120"/>
+            <a:off x="731520" y="4663440"/>
+            <a:ext cx="5120640" cy="1371600"/>
           </a:xfrm>
           <a:prstGeom prst="roundRect">
             <a:avLst/>
@@ -6132,8 +6161,8 @@
         </p:nvSpPr>
         <p:spPr>
           <a:xfrm>
-            <a:off x="8275320" y="1874520"/>
-            <a:ext cx="2926080" cy="3931920"/>
+            <a:off x="914400" y="4773168"/>
+            <a:ext cx="4754880" cy="1152144"/>
           </a:xfrm>
           <a:prstGeom prst="rect">
             <a:avLst/>
@@ -6148,94 +6177,161 @@
           <a:p>
             <a:pPr>
               <a:spcAft>
-                <a:spcPts val="600"/>
-              </a:spcAft>
-              <a:defRPr sz="1300" b="1">
+                <a:spcPts val="200"/>
+              </a:spcAft>
+              <a:defRPr sz="1000" b="1">
                 <a:solidFill>
                   <a:srgbClr val="10B981"/>
                 </a:solidFill>
+              </a:defRPr>
+            </a:pPr>
+            <a:r>
+              <a:t>03 · ENTERPRISE COMPLIANCE</a:t>
+            </a:r>
+          </a:p>
+          <a:p>
+            <a:pPr>
+              <a:spcAft>
+                <a:spcPts val="400"/>
+              </a:spcAft>
+              <a:defRPr sz="1400" b="1">
+                <a:solidFill>
+                  <a:srgbClr val="FFFFFF"/>
+                </a:solidFill>
+              </a:defRPr>
+            </a:pPr>
+            <a:r>
+              <a:t>Pre-Regulatory Regression Testing</a:t>
+            </a:r>
+          </a:p>
+          <a:p>
+            <a:pPr>
+              <a:defRPr sz="1100">
+                <a:solidFill>
+                  <a:srgbClr val="CBD5E1"/>
+                </a:solidFill>
+              </a:defRPr>
+            </a:pPr>
+            <a:r>
+              <a:t>Enables retail brands to audit their own checkout funnels and third-party plugins before regulatory scrutiny or customer backlash.</a:t>
+            </a:r>
+          </a:p>
+        </p:txBody>
+      </p:sp>
+      <p:sp>
+        <p:nvSpPr>
+          <p:cNvPr id="10" name="Rounded Rectangle 9"/>
+          <p:cNvSpPr/>
+          <p:nvPr/>
+        </p:nvSpPr>
+        <p:spPr>
+          <a:xfrm>
+            <a:off x="6217920" y="1645920"/>
+            <a:ext cx="5212080" cy="4206240"/>
+          </a:xfrm>
+          <a:prstGeom prst="roundRect">
+            <a:avLst/>
+          </a:prstGeom>
+          <a:solidFill>
+            <a:srgbClr val="0E1626"/>
+          </a:solidFill>
+          <a:ln w="19050">
+            <a:solidFill>
+              <a:srgbClr val="3B82F6"/>
+            </a:solidFill>
+          </a:ln>
+        </p:spPr>
+        <p:style>
+          <a:lnRef idx="1">
+            <a:schemeClr val="accent1"/>
+          </a:lnRef>
+          <a:fillRef idx="3">
+            <a:schemeClr val="accent1"/>
+          </a:fillRef>
+          <a:effectRef idx="2">
+            <a:schemeClr val="accent1"/>
+          </a:effectRef>
+          <a:fontRef idx="minor">
+            <a:schemeClr val="lt1"/>
+          </a:fontRef>
+        </p:style>
+        <p:txBody>
+          <a:bodyPr rtlCol="0" anchor="ctr"/>
+          <a:lstStyle/>
+          <a:p>
+            <a:pPr algn="ctr"/>
+          </a:p>
+        </p:txBody>
+      </p:sp>
+      <p:pic>
+        <p:nvPicPr>
+          <p:cNvPr id="11" name="Picture 10" descr="08_complaint_draft_modal_1440x900.png"/>
+          <p:cNvPicPr>
+            <a:picLocks noChangeAspect="1"/>
+          </p:cNvPicPr>
+          <p:nvPr/>
+        </p:nvPicPr>
+        <p:blipFill>
+          <a:blip r:embed="rId2"/>
+          <a:stretch>
+            <a:fillRect/>
+          </a:stretch>
+        </p:blipFill>
+        <p:spPr>
+          <a:xfrm>
+            <a:off x="6291072" y="1719072"/>
+            <a:ext cx="5065776" cy="4059936"/>
+          </a:xfrm>
+          <a:prstGeom prst="rect">
+            <a:avLst/>
+          </a:prstGeom>
+        </p:spPr>
+      </p:pic>
+      <p:sp>
+        <p:nvSpPr>
+          <p:cNvPr id="12" name="TextBox 11"/>
+          <p:cNvSpPr txBox="1"/>
+          <p:nvPr/>
+        </p:nvSpPr>
+        <p:spPr>
+          <a:xfrm>
+            <a:off x="6217920" y="5907024"/>
+            <a:ext cx="5212080" cy="365760"/>
+          </a:xfrm>
+          <a:prstGeom prst="rect">
+            <a:avLst/>
+          </a:prstGeom>
+          <a:noFill/>
+        </p:spPr>
+        <p:txBody>
+          <a:bodyPr wrap="square" tIns="0" lIns="0">
+            <a:spAutoFit/>
+          </a:bodyPr>
+          <a:lstStyle/>
+          <a:p>
+            <a:pPr>
+              <a:defRPr sz="1000" i="1">
+                <a:solidFill>
+                  <a:srgbClr val="94A3B8"/>
+                </a:solidFill>
                 <a:latin typeface="Arial"/>
               </a:defRPr>
             </a:pPr>
             <a:r>
-              <a:t>Enterprise Compliance</a:t>
-            </a:r>
-          </a:p>
-          <a:p>
-            <a:pPr>
-              <a:spcAft>
-                <a:spcPts val="1400"/>
-              </a:spcAft>
-              <a:defRPr sz="1800" b="1">
-                <a:solidFill>
-                  <a:srgbClr val="FFFFFF"/>
-                </a:solidFill>
-                <a:latin typeface="Arial"/>
-              </a:defRPr>
-            </a:pPr>
-            <a:r>
-              <a:t>Proactive Pre-Regulatory Auditing</a:t>
-            </a:r>
-          </a:p>
-          <a:p>
-            <a:pPr>
-              <a:spcAft>
-                <a:spcPts val="1000"/>
-              </a:spcAft>
-              <a:defRPr sz="1200">
-                <a:solidFill>
-                  <a:srgbClr val="CBD5E1"/>
-                </a:solidFill>
-                <a:latin typeface="Arial"/>
-              </a:defRPr>
-            </a:pPr>
-            <a:r>
-              <a:t>•  Outside-in regression testing for e-commerce brands before regulatory scrutiny.</a:t>
-            </a:r>
-          </a:p>
-          <a:p>
-            <a:pPr>
-              <a:spcAft>
-                <a:spcPts val="1000"/>
-              </a:spcAft>
-              <a:defRPr sz="1200">
-                <a:solidFill>
-                  <a:srgbClr val="CBD5E1"/>
-                </a:solidFill>
-                <a:latin typeface="Arial"/>
-              </a:defRPr>
-            </a:pPr>
-            <a:r>
-              <a:t>•  Audit internal Shopify, WooCommerce, or custom storefronts against CCPA 2023 rules.</a:t>
-            </a:r>
-          </a:p>
-          <a:p>
-            <a:pPr>
-              <a:spcAft>
-                <a:spcPts val="1000"/>
-              </a:spcAft>
-              <a:defRPr sz="1200">
-                <a:solidFill>
-                  <a:srgbClr val="CBD5E1"/>
-                </a:solidFill>
-                <a:latin typeface="Arial"/>
-              </a:defRPr>
-            </a:pPr>
-            <a:r>
-              <a:t>•  Identify unintended dark patterns introduced by third-party checkout plugins or apps.</a:t>
-            </a:r>
-          </a:p>
-        </p:txBody>
-      </p:sp>
-      <p:sp>
-        <p:nvSpPr>
-          <p:cNvPr id="10" name="TextBox 9"/>
+              <a:t>Actionable Grievance Generation: Pre-filled National Consumer Helpline complaint draft with statutory CCPA citations and evidence links.</a:t>
+            </a:r>
+          </a:p>
+        </p:txBody>
+      </p:sp>
+      <p:sp>
+        <p:nvSpPr>
+          <p:cNvPr id="13" name="TextBox 12"/>
           <p:cNvSpPr txBox="1"/>
           <p:nvPr/>
         </p:nvSpPr>
         <p:spPr>
           <a:xfrm>
-            <a:off x="731520" y="6309360"/>
+            <a:off x="731520" y="6355080"/>
             <a:ext cx="10698480" cy="365760"/>
           </a:xfrm>
           <a:prstGeom prst="rect">
@@ -6258,7 +6354,7 @@
               </a:defRPr>
             </a:pPr>
             <a:r>
-              <a:t>Checkout Radar · AZINHACK 2026 Submission · Slide 4 of 10</a:t>
+              <a:t>Checkout Radar · AZINHACK 2026 Presentation · Slide 4 of 10</a:t>
             </a:r>
           </a:p>
         </p:txBody>
@@ -6333,7 +6429,7 @@
         <p:spPr>
           <a:xfrm>
             <a:off x="731520" y="365760"/>
-            <a:ext cx="10698480" cy="1188720"/>
+            <a:ext cx="10698480" cy="1097280"/>
           </a:xfrm>
           <a:prstGeom prst="rect">
             <a:avLst/>
@@ -6348,7 +6444,7 @@
           <a:p>
             <a:pPr>
               <a:spcAft>
-                <a:spcPts val="400"/>
+                <a:spcPts val="300"/>
               </a:spcAft>
               <a:defRPr sz="1100" b="1">
                 <a:solidFill>
@@ -6364,9 +6460,9 @@
           <a:p>
             <a:pPr>
               <a:spcAft>
-                <a:spcPts val="400"/>
-              </a:spcAft>
-              <a:defRPr sz="2600" b="1">
+                <a:spcPts val="300"/>
+              </a:spcAft>
+              <a:defRPr sz="2500" b="1">
                 <a:solidFill>
                   <a:srgbClr val="FFFFFF"/>
                 </a:solidFill>
@@ -6379,7 +6475,7 @@
           </a:p>
           <a:p>
             <a:pPr>
-              <a:defRPr sz="1300">
+              <a:defRPr sz="1200">
                 <a:solidFill>
                   <a:srgbClr val="94A3B8"/>
                 </a:solidFill>
@@ -6467,7 +6563,6 @@
                 <a:solidFill>
                   <a:srgbClr val="38BDF8"/>
                 </a:solidFill>
-                <a:latin typeface="Arial"/>
               </a:defRPr>
             </a:pPr>
             <a:r>
@@ -6483,11 +6578,10 @@
                 <a:solidFill>
                   <a:srgbClr val="CBD5E1"/>
                 </a:solidFill>
-                <a:latin typeface="Arial"/>
-              </a:defRPr>
-            </a:pPr>
-            <a:r>
-              <a:t>✓  Complex Visual DOM Navigation: Navigates modern React, Vue, Shopify, and headless checkout funnels without site-specific scrapers.</a:t>
+              </a:defRPr>
+            </a:pPr>
+            <a:r>
+              <a:t>✓  Complex Visual DOM Navigation: Navigates modern React, Vue, Shopify, and headless checkouts without custom site-specific scrapers.</a:t>
             </a:r>
           </a:p>
           <a:p>
@@ -6499,11 +6593,10 @@
                 <a:solidFill>
                   <a:srgbClr val="CBD5E1"/>
                 </a:solidFill>
-                <a:latin typeface="Arial"/>
-              </a:defRPr>
-            </a:pPr>
-            <a:r>
-              <a:t>✓  Natural Human Emulation: Automatically solves variant selection, opens cart drawers, fills guest address forms, and handles modals.</a:t>
+              </a:defRPr>
+            </a:pPr>
+            <a:r>
+              <a:t>✓  Human-Like Emulation: Solves variant selection, opens cart drawers, fills guest address forms, and handles modals.</a:t>
             </a:r>
           </a:p>
           <a:p>
@@ -6515,7 +6608,6 @@
                 <a:solidFill>
                   <a:srgbClr val="CBD5E1"/>
                 </a:solidFill>
-                <a:latin typeface="Arial"/>
               </a:defRPr>
             </a:pPr>
             <a:r>
@@ -6531,7 +6623,6 @@
                 <a:solidFill>
                   <a:srgbClr val="CBD5E1"/>
                 </a:solidFill>
-                <a:latin typeface="Arial"/>
               </a:defRPr>
             </a:pPr>
             <a:r>
@@ -6615,7 +6706,6 @@
                 <a:solidFill>
                   <a:srgbClr val="3B82F6"/>
                 </a:solidFill>
-                <a:latin typeface="Arial"/>
               </a:defRPr>
             </a:pPr>
             <a:r>
@@ -6631,7 +6721,6 @@
                 <a:solidFill>
                   <a:srgbClr val="CBD5E1"/>
                 </a:solidFill>
-                <a:latin typeface="Arial"/>
               </a:defRPr>
             </a:pPr>
             <a:r>
@@ -6647,7 +6736,6 @@
                 <a:solidFill>
                   <a:srgbClr val="CBD5E1"/>
                 </a:solidFill>
-                <a:latin typeface="Arial"/>
               </a:defRPr>
             </a:pPr>
             <a:r>
@@ -6663,7 +6751,6 @@
                 <a:solidFill>
                   <a:srgbClr val="CBD5E1"/>
                 </a:solidFill>
-                <a:latin typeface="Arial"/>
               </a:defRPr>
             </a:pPr>
             <a:r>
@@ -6679,7 +6766,6 @@
                 <a:solidFill>
                   <a:srgbClr val="CBD5E1"/>
                 </a:solidFill>
-                <a:latin typeface="Arial"/>
               </a:defRPr>
             </a:pPr>
             <a:r>
@@ -6696,7 +6782,7 @@
         </p:nvSpPr>
         <p:spPr>
           <a:xfrm>
-            <a:off x="731520" y="6309360"/>
+            <a:off x="731520" y="6355080"/>
             <a:ext cx="10698480" cy="365760"/>
           </a:xfrm>
           <a:prstGeom prst="rect">
@@ -6719,7 +6805,7 @@
               </a:defRPr>
             </a:pPr>
             <a:r>
-              <a:t>Checkout Radar · AZINHACK 2026 Submission · Slide 5 of 10</a:t>
+              <a:t>Checkout Radar · AZINHACK 2026 Presentation · Slide 5 of 10</a:t>
             </a:r>
           </a:p>
         </p:txBody>
@@ -6794,7 +6880,7 @@
         <p:spPr>
           <a:xfrm>
             <a:off x="731520" y="365760"/>
-            <a:ext cx="10698480" cy="1188720"/>
+            <a:ext cx="10698480" cy="1097280"/>
           </a:xfrm>
           <a:prstGeom prst="rect">
             <a:avLst/>
@@ -6809,7 +6895,7 @@
           <a:p>
             <a:pPr>
               <a:spcAft>
-                <a:spcPts val="400"/>
+                <a:spcPts val="300"/>
               </a:spcAft>
               <a:defRPr sz="1100" b="1">
                 <a:solidFill>
@@ -6825,9 +6911,9 @@
           <a:p>
             <a:pPr>
               <a:spcAft>
-                <a:spcPts val="400"/>
-              </a:spcAft>
-              <a:defRPr sz="2600" b="1">
+                <a:spcPts val="300"/>
+              </a:spcAft>
+              <a:defRPr sz="2500" b="1">
                 <a:solidFill>
                   <a:srgbClr val="FFFFFF"/>
                 </a:solidFill>
@@ -6840,7 +6926,7 @@
           </a:p>
           <a:p>
             <a:pPr>
-              <a:defRPr sz="1300">
+              <a:defRPr sz="1200">
                 <a:solidFill>
                   <a:srgbClr val="94A3B8"/>
                 </a:solidFill>
@@ -6922,13 +7008,12 @@
           <a:p>
             <a:pPr>
               <a:spcAft>
-                <a:spcPts val="600"/>
-              </a:spcAft>
-              <a:defRPr sz="1500" b="1">
+                <a:spcPts val="400"/>
+              </a:spcAft>
+              <a:defRPr sz="1400" b="1">
                 <a:solidFill>
                   <a:srgbClr val="38BDF8"/>
                 </a:solidFill>
-                <a:latin typeface="Arial"/>
               </a:defRPr>
             </a:pPr>
             <a:r>
@@ -6941,7 +7026,6 @@
                 <a:solidFill>
                   <a:srgbClr val="CBD5E1"/>
                 </a:solidFill>
-                <a:latin typeface="Arial"/>
               </a:defRPr>
             </a:pPr>
             <a:r>
@@ -7019,17 +7103,16 @@
           <a:p>
             <a:pPr>
               <a:spcAft>
-                <a:spcPts val="600"/>
-              </a:spcAft>
-              <a:defRPr sz="1500" b="1">
+                <a:spcPts val="400"/>
+              </a:spcAft>
+              <a:defRPr sz="1400" b="1">
                 <a:solidFill>
                   <a:srgbClr val="3B82F6"/>
                 </a:solidFill>
-                <a:latin typeface="Arial"/>
-              </a:defRPr>
-            </a:pPr>
-            <a:r>
-              <a:t>02 · Extract</a:t>
+              </a:defRPr>
+            </a:pPr>
+            <a:r>
+              <a:t>02 · Policy Extract</a:t>
             </a:r>
           </a:p>
           <a:p>
@@ -7038,7 +7121,6 @@
                 <a:solidFill>
                   <a:srgbClr val="CBD5E1"/>
                 </a:solidFill>
-                <a:latin typeface="Arial"/>
               </a:defRPr>
             </a:pPr>
             <a:r>
@@ -7116,13 +7198,12 @@
           <a:p>
             <a:pPr>
               <a:spcAft>
-                <a:spcPts val="600"/>
-              </a:spcAft>
-              <a:defRPr sz="1500" b="1">
+                <a:spcPts val="400"/>
+              </a:spcAft>
+              <a:defRPr sz="1400" b="1">
                 <a:solidFill>
                   <a:srgbClr val="8B5CF6"/>
                 </a:solidFill>
-                <a:latin typeface="Arial"/>
               </a:defRPr>
             </a:pPr>
             <a:r>
@@ -7135,11 +7216,10 @@
                 <a:solidFill>
                   <a:srgbClr val="CBD5E1"/>
                 </a:solidFill>
-                <a:latin typeface="Arial"/>
-              </a:defRPr>
-            </a:pPr>
-            <a:r>
-              <a:t>Autonomous web agent executes funnel with stop-before-payment guardrail.</a:t>
+              </a:defRPr>
+            </a:pPr>
+            <a:r>
+              <a:t>Autonomous web agent navigates funnel with stop-before-payment guardrail.</a:t>
             </a:r>
           </a:p>
         </p:txBody>
@@ -7213,13 +7293,12 @@
           <a:p>
             <a:pPr>
               <a:spcAft>
-                <a:spcPts val="600"/>
-              </a:spcAft>
-              <a:defRPr sz="1500" b="1">
+                <a:spcPts val="400"/>
+              </a:spcAft>
+              <a:defRPr sz="1400" b="1">
                 <a:solidFill>
                   <a:srgbClr val="10B981"/>
                 </a:solidFill>
-                <a:latin typeface="Arial"/>
               </a:defRPr>
             </a:pPr>
             <a:r>
@@ -7232,7 +7311,6 @@
                 <a:solidFill>
                   <a:srgbClr val="CBD5E1"/>
                 </a:solidFill>
-                <a:latin typeface="Arial"/>
               </a:defRPr>
             </a:pPr>
             <a:r>
@@ -7310,13 +7388,12 @@
           <a:p>
             <a:pPr>
               <a:spcAft>
-                <a:spcPts val="600"/>
-              </a:spcAft>
-              <a:defRPr sz="1500" b="1">
+                <a:spcPts val="400"/>
+              </a:spcAft>
+              <a:defRPr sz="1400" b="1">
                 <a:solidFill>
                   <a:srgbClr val="10B981"/>
                 </a:solidFill>
-                <a:latin typeface="Arial"/>
               </a:defRPr>
             </a:pPr>
             <a:r>
@@ -7329,11 +7406,10 @@
                 <a:solidFill>
                   <a:srgbClr val="CBD5E1"/>
                 </a:solidFill>
-                <a:latin typeface="Arial"/>
-              </a:defRPr>
-            </a:pPr>
-            <a:r>
-              <a:t>Strict minor-unit math check: Subtotal + Charges + Taxes - Discounts = Payable.</a:t>
+              </a:defRPr>
+            </a:pPr>
+            <a:r>
+              <a:t>Integer paise check: Subtotal + Charges + Taxes - Discounts == Payable.</a:t>
             </a:r>
           </a:p>
         </p:txBody>
@@ -7407,13 +7483,12 @@
           <a:p>
             <a:pPr>
               <a:spcAft>
-                <a:spcPts val="600"/>
-              </a:spcAft>
-              <a:defRPr sz="1500" b="1">
+                <a:spcPts val="400"/>
+              </a:spcAft>
+              <a:defRPr sz="1400" b="1">
                 <a:solidFill>
                   <a:srgbClr val="3B82F6"/>
                 </a:solidFill>
-                <a:latin typeface="Arial"/>
               </a:defRPr>
             </a:pPr>
             <a:r>
@@ -7426,11 +7501,10 @@
                 <a:solidFill>
                   <a:srgbClr val="CBD5E1"/>
                 </a:solidFill>
-                <a:latin typeface="Arial"/>
-              </a:defRPr>
-            </a:pPr>
-            <a:r>
-              <a:t>Matched-pair analysis evaluates 5 diff types across isolated dimensions.</a:t>
+              </a:defRPr>
+            </a:pPr>
+            <a:r>
+              <a:t>Matched-pair engine computes 5 diff types across isolated dimensions.</a:t>
             </a:r>
           </a:p>
         </p:txBody>
@@ -7504,17 +7578,16 @@
           <a:p>
             <a:pPr>
               <a:spcAft>
-                <a:spcPts val="600"/>
-              </a:spcAft>
-              <a:defRPr sz="1500" b="1">
+                <a:spcPts val="400"/>
+              </a:spcAft>
+              <a:defRPr sz="1400" b="1">
                 <a:solidFill>
                   <a:srgbClr val="EF4444"/>
                 </a:solidFill>
-                <a:latin typeface="Arial"/>
-              </a:defRPr>
-            </a:pPr>
-            <a:r>
-              <a:t>07 · Detect</a:t>
+              </a:defRPr>
+            </a:pPr>
+            <a:r>
+              <a:t>07 · CCPA Detect</a:t>
             </a:r>
           </a:p>
           <a:p>
@@ -7523,11 +7596,10 @@
                 <a:solidFill>
                   <a:srgbClr val="CBD5E1"/>
                 </a:solidFill>
-                <a:latin typeface="Arial"/>
-              </a:defRPr>
-            </a:pPr>
-            <a:r>
-              <a:t>Deterministic rules match CCPA Annex 1.8 (Drip), 1.2 (Sneak), 1.1 (Urgency).</a:t>
+              </a:defRPr>
+            </a:pPr>
+            <a:r>
+              <a:t>Deterministic rules match Annex 1.8 (Drip), 1.2 (Sneak), 1.1 (Urgency).</a:t>
             </a:r>
           </a:p>
         </p:txBody>
@@ -7601,17 +7673,16 @@
           <a:p>
             <a:pPr>
               <a:spcAft>
-                <a:spcPts val="600"/>
-              </a:spcAft>
-              <a:defRPr sz="1500" b="1">
+                <a:spcPts val="400"/>
+              </a:spcAft>
+              <a:defRPr sz="1400" b="1">
                 <a:solidFill>
                   <a:srgbClr val="38BDF8"/>
                 </a:solidFill>
-                <a:latin typeface="Arial"/>
-              </a:defRPr>
-            </a:pPr>
-            <a:r>
-              <a:t>08 · Report</a:t>
+              </a:defRPr>
+            </a:pPr>
+            <a:r>
+              <a:t>08 · Report &amp; Draft</a:t>
             </a:r>
           </a:p>
           <a:p>
@@ -7620,11 +7691,10 @@
                 <a:solidFill>
                   <a:srgbClr val="CBD5E1"/>
                 </a:solidFill>
-                <a:latin typeface="Arial"/>
-              </a:defRPr>
-            </a:pPr>
-            <a:r>
-              <a:t>Generates self-contained HTML evidence dossier and NCH complaint draft.</a:t>
+              </a:defRPr>
+            </a:pPr>
+            <a:r>
+              <a:t>Compiles self-contained HTML evidence report and editable NCH grievance.</a:t>
             </a:r>
           </a:p>
         </p:txBody>
@@ -7637,7 +7707,7 @@
         </p:nvSpPr>
         <p:spPr>
           <a:xfrm>
-            <a:off x="731520" y="6309360"/>
+            <a:off x="731520" y="6355080"/>
             <a:ext cx="10698480" cy="365760"/>
           </a:xfrm>
           <a:prstGeom prst="rect">
@@ -7660,7 +7730,7 @@
               </a:defRPr>
             </a:pPr>
             <a:r>
-              <a:t>Checkout Radar · AZINHACK 2026 Submission · Slide 6 of 10</a:t>
+              <a:t>Checkout Radar · AZINHACK 2026 Presentation · Slide 6 of 10</a:t>
             </a:r>
           </a:p>
         </p:txBody>
@@ -7735,7 +7805,7 @@
         <p:spPr>
           <a:xfrm>
             <a:off x="731520" y="365760"/>
-            <a:ext cx="10698480" cy="1188720"/>
+            <a:ext cx="10698480" cy="1097280"/>
           </a:xfrm>
           <a:prstGeom prst="rect">
             <a:avLst/>
@@ -7750,7 +7820,7 @@
           <a:p>
             <a:pPr>
               <a:spcAft>
-                <a:spcPts val="400"/>
+                <a:spcPts val="300"/>
               </a:spcAft>
               <a:defRPr sz="1100" b="1">
                 <a:solidFill>
@@ -7766,9 +7836,9 @@
           <a:p>
             <a:pPr>
               <a:spcAft>
-                <a:spcPts val="400"/>
-              </a:spcAft>
-              <a:defRPr sz="2600" b="1">
+                <a:spcPts val="300"/>
+              </a:spcAft>
+              <a:defRPr sz="2500" b="1">
                 <a:solidFill>
                   <a:srgbClr val="FFFFFF"/>
                 </a:solidFill>
@@ -7776,12 +7846,12 @@
               </a:defRPr>
             </a:pPr>
             <a:r>
-              <a:t>Deep Platform Integration Across the Complete API Surface</a:t>
-            </a:r>
-          </a:p>
-          <a:p>
-            <a:pPr>
-              <a:defRPr sz="1300">
+              <a:t>In the Primary Path Across the Complete TinyFish API Surface</a:t>
+            </a:r>
+          </a:p>
+          <a:p>
+            <a:pPr>
+              <a:defRPr sz="1200">
                 <a:solidFill>
                   <a:srgbClr val="94A3B8"/>
                 </a:solidFill>
@@ -7789,7 +7859,7 @@
               </a:defRPr>
             </a:pPr>
             <a:r>
-              <a:t>TinyFish is in the main execution path across Search, Fetch, Agent, and Profiles APIs.</a:t>
+              <a:t>TinyFish is central to Checkout Radar across Search, Fetch, Agent, and Profiles APIs.</a:t>
             </a:r>
           </a:p>
         </p:txBody>
@@ -7803,7 +7873,7 @@
         <p:spPr>
           <a:xfrm>
             <a:off x="731520" y="1645920"/>
-            <a:ext cx="5212080" cy="2057400"/>
+            <a:ext cx="5120640" cy="1051560"/>
           </a:xfrm>
           <a:prstGeom prst="roundRect">
             <a:avLst/>
@@ -7847,8 +7917,8 @@
         </p:nvSpPr>
         <p:spPr>
           <a:xfrm>
-            <a:off x="914400" y="1810512"/>
-            <a:ext cx="4846320" cy="1728216"/>
+            <a:off x="914400" y="1737360"/>
+            <a:ext cx="4754880" cy="868680"/>
           </a:xfrm>
           <a:prstGeom prst="rect">
             <a:avLst/>
@@ -7865,44 +7935,26 @@
               <a:spcAft>
                 <a:spcPts val="200"/>
               </a:spcAft>
-              <a:defRPr sz="1600" b="1">
+              <a:defRPr sz="1200" b="1">
                 <a:solidFill>
                   <a:srgbClr val="38BDF8"/>
                 </a:solidFill>
-                <a:latin typeface="Arial"/>
-              </a:defRPr>
-            </a:pPr>
-            <a:r>
-              <a:t>🔍 TinyFish Search API</a:t>
-            </a:r>
-          </a:p>
-          <a:p>
-            <a:pPr>
-              <a:spcAft>
-                <a:spcPts val="600"/>
-              </a:spcAft>
-              <a:defRPr sz="1200" b="1">
-                <a:solidFill>
-                  <a:srgbClr val="FFFFFF"/>
-                </a:solidFill>
-                <a:latin typeface="Arial"/>
-              </a:defRPr>
-            </a:pPr>
-            <a:r>
-              <a:t>Merchant Terms &amp; Policy Discovery</a:t>
-            </a:r>
-          </a:p>
-          <a:p>
-            <a:pPr>
-              <a:defRPr sz="1100">
+              </a:defRPr>
+            </a:pPr>
+            <a:r>
+              <a:t>🔍 TinyFish Search API  ·  Merchant Terms &amp; Policy Discovery</a:t>
+            </a:r>
+          </a:p>
+          <a:p>
+            <a:pPr>
+              <a:defRPr sz="1000">
                 <a:solidFill>
                   <a:srgbClr val="CBD5E1"/>
                 </a:solidFill>
-                <a:latin typeface="Arial"/>
-              </a:defRPr>
-            </a:pPr>
-            <a:r>
-              <a:t>Discovers merchant declared terms of service, fee disclosures, and return policies during audit initiation without manual URL hunting.</a:t>
+              </a:defRPr>
+            </a:pPr>
+            <a:r>
+              <a:t>Queries merchant terms and fee declarations prior to audit.</a:t>
             </a:r>
           </a:p>
         </p:txBody>
@@ -7915,8 +7967,8 @@
         </p:nvSpPr>
         <p:spPr>
           <a:xfrm>
-            <a:off x="6217920" y="1645920"/>
-            <a:ext cx="5212080" cy="2057400"/>
+            <a:off x="731520" y="2788920"/>
+            <a:ext cx="5120640" cy="1051560"/>
           </a:xfrm>
           <a:prstGeom prst="roundRect">
             <a:avLst/>
@@ -7960,8 +8012,8 @@
         </p:nvSpPr>
         <p:spPr>
           <a:xfrm>
-            <a:off x="6400800" y="1810512"/>
-            <a:ext cx="4846320" cy="1728216"/>
+            <a:off x="914400" y="2880360"/>
+            <a:ext cx="4754880" cy="868680"/>
           </a:xfrm>
           <a:prstGeom prst="rect">
             <a:avLst/>
@@ -7978,44 +8030,26 @@
               <a:spcAft>
                 <a:spcPts val="200"/>
               </a:spcAft>
-              <a:defRPr sz="1600" b="1">
+              <a:defRPr sz="1200" b="1">
                 <a:solidFill>
                   <a:srgbClr val="3B82F6"/>
                 </a:solidFill>
-                <a:latin typeface="Arial"/>
-              </a:defRPr>
-            </a:pPr>
-            <a:r>
-              <a:t>📄 TinyFish Fetch API</a:t>
-            </a:r>
-          </a:p>
-          <a:p>
-            <a:pPr>
-              <a:spcAft>
-                <a:spcPts val="600"/>
-              </a:spcAft>
-              <a:defRPr sz="1200" b="1">
-                <a:solidFill>
-                  <a:srgbClr val="FFFFFF"/>
-                </a:solidFill>
-                <a:latin typeface="Arial"/>
-              </a:defRPr>
-            </a:pPr>
-            <a:r>
-              <a:t>Clean Markdown Extraction with TTL Caching</a:t>
-            </a:r>
-          </a:p>
-          <a:p>
-            <a:pPr>
-              <a:defRPr sz="1100">
+              </a:defRPr>
+            </a:pPr>
+            <a:r>
+              <a:t>📄 TinyFish Fetch API  ·  Clean Markdown Extraction with TTL Cache</a:t>
+            </a:r>
+          </a:p>
+          <a:p>
+            <a:pPr>
+              <a:defRPr sz="1000">
                 <a:solidFill>
                   <a:srgbClr val="CBD5E1"/>
                 </a:solidFill>
-                <a:latin typeface="Arial"/>
-              </a:defRPr>
-            </a:pPr>
-            <a:r>
-              <a:t>Extracts clean policy text with intelligent caching: ttl: 0 for dynamic checkout flows, ttl: 3600 for static terms to conserve API quota.</a:t>
+              </a:defRPr>
+            </a:pPr>
+            <a:r>
+              <a:t>Extracts clean policy text with intelligent caching (ttl: 0 vs ttl: 3600).</a:t>
             </a:r>
           </a:p>
         </p:txBody>
@@ -8028,8 +8062,8 @@
         </p:nvSpPr>
         <p:spPr>
           <a:xfrm>
-            <a:off x="731520" y="3977640"/>
-            <a:ext cx="5212080" cy="2057400"/>
+            <a:off x="731520" y="3931920"/>
+            <a:ext cx="5120640" cy="1051560"/>
           </a:xfrm>
           <a:prstGeom prst="roundRect">
             <a:avLst/>
@@ -8073,8 +8107,8 @@
         </p:nvSpPr>
         <p:spPr>
           <a:xfrm>
-            <a:off x="914400" y="4142232"/>
-            <a:ext cx="4846320" cy="1728216"/>
+            <a:off x="914400" y="4023360"/>
+            <a:ext cx="4754880" cy="868680"/>
           </a:xfrm>
           <a:prstGeom prst="rect">
             <a:avLst/>
@@ -8091,44 +8125,26 @@
               <a:spcAft>
                 <a:spcPts val="200"/>
               </a:spcAft>
-              <a:defRPr sz="1600" b="1">
+              <a:defRPr sz="1200" b="1">
                 <a:solidFill>
                   <a:srgbClr val="10B981"/>
                 </a:solidFill>
-                <a:latin typeface="Arial"/>
-              </a:defRPr>
-            </a:pPr>
-            <a:r>
-              <a:t>🤖 TinyFish Agent API</a:t>
-            </a:r>
-          </a:p>
-          <a:p>
-            <a:pPr>
-              <a:spcAft>
-                <a:spcPts val="600"/>
-              </a:spcAft>
-              <a:defRPr sz="1200" b="1">
-                <a:solidFill>
-                  <a:srgbClr val="FFFFFF"/>
-                </a:solidFill>
-                <a:latin typeface="Arial"/>
-              </a:defRPr>
-            </a:pPr>
-            <a:r>
-              <a:t>Cloud Browser Navigation (Stop-Before-Payment)</a:t>
-            </a:r>
-          </a:p>
-          <a:p>
-            <a:pPr>
-              <a:defRPr sz="1100">
+              </a:defRPr>
+            </a:pPr>
+            <a:r>
+              <a:t>🤖 TinyFish Agent API  ·  Cloud Browser Navigation (Stop-Before-Payment)</a:t>
+            </a:r>
+          </a:p>
+          <a:p>
+            <a:pPr>
+              <a:defRPr sz="1000">
                 <a:solidFill>
                   <a:srgbClr val="CBD5E1"/>
                 </a:solidFill>
-                <a:latin typeface="Arial"/>
-              </a:defRPr>
-            </a:pPr>
-            <a:r>
-              <a:t>Executes multi-step browser automations across product, cart, and summary states under strict CCPA safety guardrails.</a:t>
+              </a:defRPr>
+            </a:pPr>
+            <a:r>
+              <a:t>Executes multi-step browser automations under strict safety guardrails.</a:t>
             </a:r>
           </a:p>
         </p:txBody>
@@ -8141,8 +8157,8 @@
         </p:nvSpPr>
         <p:spPr>
           <a:xfrm>
-            <a:off x="6217920" y="3977640"/>
-            <a:ext cx="5212080" cy="2057400"/>
+            <a:off x="731520" y="5074920"/>
+            <a:ext cx="5120640" cy="1051560"/>
           </a:xfrm>
           <a:prstGeom prst="roundRect">
             <a:avLst/>
@@ -8186,8 +8202,8 @@
         </p:nvSpPr>
         <p:spPr>
           <a:xfrm>
-            <a:off x="6400800" y="4142232"/>
-            <a:ext cx="4846320" cy="1728216"/>
+            <a:off x="914400" y="5166360"/>
+            <a:ext cx="4754880" cy="868680"/>
           </a:xfrm>
           <a:prstGeom prst="rect">
             <a:avLst/>
@@ -8204,57 +8220,144 @@
               <a:spcAft>
                 <a:spcPts val="200"/>
               </a:spcAft>
-              <a:defRPr sz="1600" b="1">
+              <a:defRPr sz="1200" b="1">
                 <a:solidFill>
                   <a:srgbClr val="8B5CF6"/>
                 </a:solidFill>
+              </a:defRPr>
+            </a:pPr>
+            <a:r>
+              <a:t>🛡️ TinyFish Profiles API  ·  State-Isolated Browser Contexts</a:t>
+            </a:r>
+          </a:p>
+          <a:p>
+            <a:pPr>
+              <a:defRPr sz="1000">
+                <a:solidFill>
+                  <a:srgbClr val="CBD5E1"/>
+                </a:solidFill>
+              </a:defRPr>
+            </a:pPr>
+            <a:r>
+              <a:t>Spawns isolated profiles for returning conditions, preventing cookie leakage.</a:t>
+            </a:r>
+          </a:p>
+        </p:txBody>
+      </p:sp>
+      <p:sp>
+        <p:nvSpPr>
+          <p:cNvPr id="12" name="Rounded Rectangle 11"/>
+          <p:cNvSpPr/>
+          <p:nvPr/>
+        </p:nvSpPr>
+        <p:spPr>
+          <a:xfrm>
+            <a:off x="6217920" y="1645920"/>
+            <a:ext cx="5212080" cy="4206240"/>
+          </a:xfrm>
+          <a:prstGeom prst="roundRect">
+            <a:avLst/>
+          </a:prstGeom>
+          <a:solidFill>
+            <a:srgbClr val="0E1626"/>
+          </a:solidFill>
+          <a:ln w="19050">
+            <a:solidFill>
+              <a:srgbClr val="3B82F6"/>
+            </a:solidFill>
+          </a:ln>
+        </p:spPr>
+        <p:style>
+          <a:lnRef idx="1">
+            <a:schemeClr val="accent1"/>
+          </a:lnRef>
+          <a:fillRef idx="3">
+            <a:schemeClr val="accent1"/>
+          </a:fillRef>
+          <a:effectRef idx="2">
+            <a:schemeClr val="accent1"/>
+          </a:effectRef>
+          <a:fontRef idx="minor">
+            <a:schemeClr val="lt1"/>
+          </a:fontRef>
+        </p:style>
+        <p:txBody>
+          <a:bodyPr rtlCol="0" anchor="ctr"/>
+          <a:lstStyle/>
+          <a:p>
+            <a:pPr algn="ctr"/>
+          </a:p>
+        </p:txBody>
+      </p:sp>
+      <p:pic>
+        <p:nvPicPr>
+          <p:cNvPr id="13" name="Picture 12" descr="02_clean_audit_viewport_1440x900.png"/>
+          <p:cNvPicPr>
+            <a:picLocks noChangeAspect="1"/>
+          </p:cNvPicPr>
+          <p:nvPr/>
+        </p:nvPicPr>
+        <p:blipFill>
+          <a:blip r:embed="rId2"/>
+          <a:stretch>
+            <a:fillRect/>
+          </a:stretch>
+        </p:blipFill>
+        <p:spPr>
+          <a:xfrm>
+            <a:off x="6291072" y="1719072"/>
+            <a:ext cx="5065776" cy="4059936"/>
+          </a:xfrm>
+          <a:prstGeom prst="rect">
+            <a:avLst/>
+          </a:prstGeom>
+        </p:spPr>
+      </p:pic>
+      <p:sp>
+        <p:nvSpPr>
+          <p:cNvPr id="14" name="TextBox 13"/>
+          <p:cNvSpPr txBox="1"/>
+          <p:nvPr/>
+        </p:nvSpPr>
+        <p:spPr>
+          <a:xfrm>
+            <a:off x="6217920" y="5907024"/>
+            <a:ext cx="5212080" cy="365760"/>
+          </a:xfrm>
+          <a:prstGeom prst="rect">
+            <a:avLst/>
+          </a:prstGeom>
+          <a:noFill/>
+        </p:spPr>
+        <p:txBody>
+          <a:bodyPr wrap="square" tIns="0" lIns="0">
+            <a:spAutoFit/>
+          </a:bodyPr>
+          <a:lstStyle/>
+          <a:p>
+            <a:pPr>
+              <a:defRPr sz="1000" i="1">
+                <a:solidFill>
+                  <a:srgbClr val="94A3B8"/>
+                </a:solidFill>
                 <a:latin typeface="Arial"/>
               </a:defRPr>
             </a:pPr>
             <a:r>
-              <a:t>🛡️ TinyFish Profiles API</a:t>
-            </a:r>
-          </a:p>
-          <a:p>
-            <a:pPr>
-              <a:spcAft>
-                <a:spcPts val="600"/>
-              </a:spcAft>
-              <a:defRPr sz="1200" b="1">
-                <a:solidFill>
-                  <a:srgbClr val="FFFFFF"/>
-                </a:solidFill>
-                <a:latin typeface="Arial"/>
-              </a:defRPr>
-            </a:pPr>
-            <a:r>
-              <a:t>State-Isolated Browser Contexts</a:t>
-            </a:r>
-          </a:p>
-          <a:p>
-            <a:pPr>
-              <a:defRPr sz="1100">
-                <a:solidFill>
-                  <a:srgbClr val="CBD5E1"/>
-                </a:solidFill>
-                <a:latin typeface="Arial"/>
-              </a:defRPr>
-            </a:pPr>
-            <a:r>
-              <a:t>Spawns isolated browser context profiles for returning visitor conditions, preventing cookie and session leakage between matrix runs.</a:t>
-            </a:r>
-          </a:p>
-        </p:txBody>
-      </p:sp>
-      <p:sp>
-        <p:nvSpPr>
-          <p:cNvPr id="12" name="TextBox 11"/>
+              <a:t>Empirically verified live audit of Headphone Zone: 51 provider calls logged, 0 hidden fees, and verified clean outcome.</a:t>
+            </a:r>
+          </a:p>
+        </p:txBody>
+      </p:sp>
+      <p:sp>
+        <p:nvSpPr>
+          <p:cNvPr id="15" name="TextBox 14"/>
           <p:cNvSpPr txBox="1"/>
           <p:nvPr/>
         </p:nvSpPr>
         <p:spPr>
           <a:xfrm>
-            <a:off x="731520" y="6309360"/>
+            <a:off x="731520" y="6355080"/>
             <a:ext cx="10698480" cy="365760"/>
           </a:xfrm>
           <a:prstGeom prst="rect">
@@ -8277,7 +8380,7 @@
               </a:defRPr>
             </a:pPr>
             <a:r>
-              <a:t>Checkout Radar · AZINHACK 2026 Submission · Slide 7 of 10</a:t>
+              <a:t>Checkout Radar · AZINHACK 2026 Presentation · Slide 7 of 10</a:t>
             </a:r>
           </a:p>
         </p:txBody>
@@ -8352,7 +8455,7 @@
         <p:spPr>
           <a:xfrm>
             <a:off x="731520" y="365760"/>
-            <a:ext cx="10698480" cy="1188720"/>
+            <a:ext cx="10698480" cy="1097280"/>
           </a:xfrm>
           <a:prstGeom prst="rect">
             <a:avLst/>
@@ -8367,7 +8470,7 @@
           <a:p>
             <a:pPr>
               <a:spcAft>
-                <a:spcPts val="400"/>
+                <a:spcPts val="300"/>
               </a:spcAft>
               <a:defRPr sz="1100" b="1">
                 <a:solidFill>
@@ -8383,9 +8486,9 @@
           <a:p>
             <a:pPr>
               <a:spcAft>
-                <a:spcPts val="400"/>
-              </a:spcAft>
-              <a:defRPr sz="2600" b="1">
+                <a:spcPts val="300"/>
+              </a:spcAft>
+              <a:defRPr sz="2500" b="1">
                 <a:solidFill>
                   <a:srgbClr val="FFFFFF"/>
                 </a:solidFill>
@@ -8398,7 +8501,7 @@
           </a:p>
           <a:p>
             <a:pPr>
-              <a:defRPr sz="1300">
+              <a:defRPr sz="1200">
                 <a:solidFill>
                   <a:srgbClr val="94A3B8"/>
                 </a:solidFill>
@@ -8406,7 +8509,7 @@
               </a:defRPr>
             </a:pPr>
             <a:r>
-              <a:t>Real-world impact metrics measured on synthetic benchmarks and live merchant audits.</a:t>
+              <a:t>Measurable results proven across synthetic benchmarks and live merchant audits.</a:t>
             </a:r>
           </a:p>
         </p:txBody>
@@ -8419,8 +8522,8 @@
         </p:nvSpPr>
         <p:spPr>
           <a:xfrm>
-            <a:off x="731520" y="1645920"/>
-            <a:ext cx="5212080" cy="2057400"/>
+            <a:off x="731520" y="1600200"/>
+            <a:ext cx="2514600" cy="868680"/>
           </a:xfrm>
           <a:prstGeom prst="roundRect">
             <a:avLst/>
@@ -8464,8 +8567,8 @@
         </p:nvSpPr>
         <p:spPr>
           <a:xfrm>
-            <a:off x="960120" y="1810512"/>
-            <a:ext cx="4754880" cy="1728216"/>
+            <a:off x="841248" y="1664208"/>
+            <a:ext cx="2295144" cy="731520"/>
           </a:xfrm>
           <a:prstGeom prst="rect">
             <a:avLst/>
@@ -8482,44 +8585,26 @@
               <a:spcAft>
                 <a:spcPts val="200"/>
               </a:spcAft>
-              <a:defRPr sz="2800" b="1">
+              <a:defRPr sz="1800" b="1">
                 <a:solidFill>
                   <a:srgbClr val="38BDF8"/>
                 </a:solidFill>
-                <a:latin typeface="Arial"/>
-              </a:defRPr>
-            </a:pPr>
-            <a:r>
-              <a:t>45 min ➔ 30 sec</a:t>
-            </a:r>
-          </a:p>
-          <a:p>
-            <a:pPr>
-              <a:spcAft>
-                <a:spcPts val="600"/>
-              </a:spcAft>
-              <a:defRPr sz="1400" b="1">
-                <a:solidFill>
-                  <a:srgbClr val="FFFFFF"/>
-                </a:solidFill>
-                <a:latin typeface="Arial"/>
-              </a:defRPr>
-            </a:pPr>
-            <a:r>
-              <a:t>Consumer Grievance Velocity</a:t>
-            </a:r>
-          </a:p>
-          <a:p>
-            <a:pPr>
-              <a:defRPr sz="1100">
-                <a:solidFill>
-                  <a:srgbClr val="CBD5E1"/>
-                </a:solidFill>
-                <a:latin typeface="Arial"/>
-              </a:defRPr>
-            </a:pPr>
-            <a:r>
-              <a:t>Reduces the time to document, verify, and draft an actionable CCPA dark pattern complaint from 45 minutes to 30 seconds with 1-click export.</a:t>
+              </a:defRPr>
+            </a:pPr>
+            <a:r>
+              <a:t>45m ➔ 30s</a:t>
+            </a:r>
+          </a:p>
+          <a:p>
+            <a:pPr>
+              <a:defRPr sz="1000">
+                <a:solidFill>
+                  <a:srgbClr val="94A3B8"/>
+                </a:solidFill>
+              </a:defRPr>
+            </a:pPr>
+            <a:r>
+              <a:t>Grievance Velocity</a:t>
             </a:r>
           </a:p>
         </p:txBody>
@@ -8532,8 +8617,8 @@
         </p:nvSpPr>
         <p:spPr>
           <a:xfrm>
-            <a:off x="6217920" y="1645920"/>
-            <a:ext cx="5212080" cy="2057400"/>
+            <a:off x="3456432" y="1600200"/>
+            <a:ext cx="2514600" cy="868680"/>
           </a:xfrm>
           <a:prstGeom prst="roundRect">
             <a:avLst/>
@@ -8577,8 +8662,8 @@
         </p:nvSpPr>
         <p:spPr>
           <a:xfrm>
-            <a:off x="6446520" y="1810512"/>
-            <a:ext cx="4754880" cy="1728216"/>
+            <a:off x="3566160" y="1664208"/>
+            <a:ext cx="2295144" cy="731520"/>
           </a:xfrm>
           <a:prstGeom prst="rect">
             <a:avLst/>
@@ -8595,44 +8680,26 @@
               <a:spcAft>
                 <a:spcPts val="200"/>
               </a:spcAft>
-              <a:defRPr sz="2800" b="1">
+              <a:defRPr sz="1800" b="1">
                 <a:solidFill>
                   <a:srgbClr val="10B981"/>
                 </a:solidFill>
-                <a:latin typeface="Arial"/>
-              </a:defRPr>
-            </a:pPr>
-            <a:r>
-              <a:t>100% Precision</a:t>
-            </a:r>
-          </a:p>
-          <a:p>
-            <a:pPr>
-              <a:spcAft>
-                <a:spcPts val="600"/>
-              </a:spcAft>
-              <a:defRPr sz="1400" b="1">
-                <a:solidFill>
-                  <a:srgbClr val="FFFFFF"/>
-                </a:solidFill>
-                <a:latin typeface="Arial"/>
-              </a:defRPr>
-            </a:pPr>
-            <a:r>
-              <a:t>Algorithmic Conformance</a:t>
-            </a:r>
-          </a:p>
-          <a:p>
-            <a:pPr>
-              <a:defRPr sz="1100">
-                <a:solidFill>
-                  <a:srgbClr val="CBD5E1"/>
-                </a:solidFill>
-                <a:latin typeface="Arial"/>
-              </a:defRPr>
-            </a:pPr>
-            <a:r>
-              <a:t>100% precision, 100% recall, and F1 = 1.000 across 45 designed scenario bundles. Zero false alarms on negative controls.</a:t>
+              </a:defRPr>
+            </a:pPr>
+            <a:r>
+              <a:t>100% / 100%</a:t>
+            </a:r>
+          </a:p>
+          <a:p>
+            <a:pPr>
+              <a:defRPr sz="1000">
+                <a:solidFill>
+                  <a:srgbClr val="94A3B8"/>
+                </a:solidFill>
+              </a:defRPr>
+            </a:pPr>
+            <a:r>
+              <a:t>Precision &amp; Recall</a:t>
             </a:r>
           </a:p>
         </p:txBody>
@@ -8645,8 +8712,8 @@
         </p:nvSpPr>
         <p:spPr>
           <a:xfrm>
-            <a:off x="731520" y="3977640"/>
-            <a:ext cx="5212080" cy="2057400"/>
+            <a:off x="6181344" y="1600200"/>
+            <a:ext cx="2514600" cy="868680"/>
           </a:xfrm>
           <a:prstGeom prst="roundRect">
             <a:avLst/>
@@ -8690,8 +8757,8 @@
         </p:nvSpPr>
         <p:spPr>
           <a:xfrm>
-            <a:off x="960120" y="4142232"/>
-            <a:ext cx="4754880" cy="1728216"/>
+            <a:off x="6291072" y="1664208"/>
+            <a:ext cx="2295144" cy="731520"/>
           </a:xfrm>
           <a:prstGeom prst="rect">
             <a:avLst/>
@@ -8708,44 +8775,26 @@
               <a:spcAft>
                 <a:spcPts val="200"/>
               </a:spcAft>
-              <a:defRPr sz="2800" b="1">
+              <a:defRPr sz="1800" b="1">
                 <a:solidFill>
                   <a:srgbClr val="3B82F6"/>
                 </a:solidFill>
-                <a:latin typeface="Arial"/>
-              </a:defRPr>
-            </a:pPr>
-            <a:r>
-              <a:t>Zero Exfiltration</a:t>
-            </a:r>
-          </a:p>
-          <a:p>
-            <a:pPr>
-              <a:spcAft>
-                <a:spcPts val="600"/>
-              </a:spcAft>
-              <a:defRPr sz="1400" b="1">
-                <a:solidFill>
-                  <a:srgbClr val="FFFFFF"/>
-                </a:solidFill>
-                <a:latin typeface="Arial"/>
-              </a:defRPr>
-            </a:pPr>
-            <a:r>
-              <a:t>Security &amp; Privacy Guarantee</a:t>
-            </a:r>
-          </a:p>
-          <a:p>
-            <a:pPr>
-              <a:defRPr sz="1100">
-                <a:solidFill>
-                  <a:srgbClr val="CBD5E1"/>
-                </a:solidFill>
-                <a:latin typeface="Arial"/>
-              </a:defRPr>
-            </a:pPr>
-            <a:r>
-              <a:t>All API credentials stored backend-only. Raw keys never touch frontend storage, reports, or logs. Form PII redacted by Pillow.</a:t>
+              </a:defRPr>
+            </a:pPr>
+            <a:r>
+              <a:t>0 Secrets</a:t>
+            </a:r>
+          </a:p>
+          <a:p>
+            <a:pPr>
+              <a:defRPr sz="1000">
+                <a:solidFill>
+                  <a:srgbClr val="94A3B8"/>
+                </a:solidFill>
+              </a:defRPr>
+            </a:pPr>
+            <a:r>
+              <a:t>Zero-Exfiltration</a:t>
             </a:r>
           </a:p>
         </p:txBody>
@@ -8758,8 +8807,8 @@
         </p:nvSpPr>
         <p:spPr>
           <a:xfrm>
-            <a:off x="6217920" y="3977640"/>
-            <a:ext cx="5212080" cy="2057400"/>
+            <a:off x="8906256" y="1600200"/>
+            <a:ext cx="2514600" cy="868680"/>
           </a:xfrm>
           <a:prstGeom prst="roundRect">
             <a:avLst/>
@@ -8803,8 +8852,8 @@
         </p:nvSpPr>
         <p:spPr>
           <a:xfrm>
-            <a:off x="6446520" y="4142232"/>
-            <a:ext cx="4754880" cy="1728216"/>
+            <a:off x="9015984" y="1664208"/>
+            <a:ext cx="2295144" cy="731520"/>
           </a:xfrm>
           <a:prstGeom prst="rect">
             <a:avLst/>
@@ -8821,57 +8870,287 @@
               <a:spcAft>
                 <a:spcPts val="200"/>
               </a:spcAft>
-              <a:defRPr sz="2800" b="1">
+              <a:defRPr sz="1800" b="1">
                 <a:solidFill>
                   <a:srgbClr val="8B5CF6"/>
                 </a:solidFill>
+              </a:defRPr>
+            </a:pPr>
+            <a:r>
+              <a:t>SHA-256</a:t>
+            </a:r>
+          </a:p>
+          <a:p>
+            <a:pPr>
+              <a:defRPr sz="1000">
+                <a:solidFill>
+                  <a:srgbClr val="94A3B8"/>
+                </a:solidFill>
+              </a:defRPr>
+            </a:pPr>
+            <a:r>
+              <a:t>Cryptographic Custody</a:t>
+            </a:r>
+          </a:p>
+        </p:txBody>
+      </p:sp>
+      <p:sp>
+        <p:nvSpPr>
+          <p:cNvPr id="12" name="Rounded Rectangle 11"/>
+          <p:cNvSpPr/>
+          <p:nvPr/>
+        </p:nvSpPr>
+        <p:spPr>
+          <a:xfrm>
+            <a:off x="731520" y="2651760"/>
+            <a:ext cx="5120640" cy="3474720"/>
+          </a:xfrm>
+          <a:prstGeom prst="roundRect">
+            <a:avLst/>
+          </a:prstGeom>
+          <a:solidFill>
+            <a:srgbClr val="0E1626"/>
+          </a:solidFill>
+          <a:ln w="19050">
+            <a:solidFill>
+              <a:srgbClr val="233148"/>
+            </a:solidFill>
+          </a:ln>
+        </p:spPr>
+        <p:style>
+          <a:lnRef idx="1">
+            <a:schemeClr val="accent1"/>
+          </a:lnRef>
+          <a:fillRef idx="3">
+            <a:schemeClr val="accent1"/>
+          </a:fillRef>
+          <a:effectRef idx="2">
+            <a:schemeClr val="accent1"/>
+          </a:effectRef>
+          <a:fontRef idx="minor">
+            <a:schemeClr val="lt1"/>
+          </a:fontRef>
+        </p:style>
+        <p:txBody>
+          <a:bodyPr rtlCol="0" anchor="ctr"/>
+          <a:lstStyle/>
+          <a:p>
+            <a:pPr algn="ctr"/>
+          </a:p>
+        </p:txBody>
+      </p:sp>
+      <p:sp>
+        <p:nvSpPr>
+          <p:cNvPr id="13" name="TextBox 12"/>
+          <p:cNvSpPr txBox="1"/>
+          <p:nvPr/>
+        </p:nvSpPr>
+        <p:spPr>
+          <a:xfrm>
+            <a:off x="960120" y="2834640"/>
+            <a:ext cx="4663440" cy="3108960"/>
+          </a:xfrm>
+          <a:prstGeom prst="rect">
+            <a:avLst/>
+          </a:prstGeom>
+          <a:noFill/>
+        </p:spPr>
+        <p:txBody>
+          <a:bodyPr wrap="square" tIns="0" lIns="0">
+            <a:spAutoFit/>
+          </a:bodyPr>
+          <a:lstStyle/>
+          <a:p>
+            <a:pPr>
+              <a:spcAft>
+                <a:spcPts val="800"/>
+              </a:spcAft>
+              <a:defRPr sz="1800" b="1">
+                <a:solidFill>
+                  <a:srgbClr val="38BDF8"/>
+                </a:solidFill>
+              </a:defRPr>
+            </a:pPr>
+            <a:r>
+              <a:t>Tangible Real-World Outcomes</a:t>
+            </a:r>
+          </a:p>
+          <a:p>
+            <a:pPr>
+              <a:spcAft>
+                <a:spcPts val="600"/>
+              </a:spcAft>
+              <a:defRPr sz="1100">
+                <a:solidFill>
+                  <a:srgbClr val="CBD5E1"/>
+                </a:solidFill>
+              </a:defRPr>
+            </a:pPr>
+            <a:r>
+              <a:t>•  98% Faster Grievance Redressal: Transforms a frustrating 45-minute manual drafting ordeal into a 30-second automated NCH export.</a:t>
+            </a:r>
+          </a:p>
+          <a:p>
+            <a:pPr>
+              <a:spcAft>
+                <a:spcPts val="600"/>
+              </a:spcAft>
+              <a:defRPr sz="1100">
+                <a:solidFill>
+                  <a:srgbClr val="CBD5E1"/>
+                </a:solidFill>
+              </a:defRPr>
+            </a:pPr>
+            <a:r>
+              <a:t>•  Zero False Accusations: 100% precision across 45 designed benchmark scenarios guarantees honest merchants are never falsely penalized.</a:t>
+            </a:r>
+          </a:p>
+          <a:p>
+            <a:pPr>
+              <a:spcAft>
+                <a:spcPts val="600"/>
+              </a:spcAft>
+              <a:defRPr sz="1100">
+                <a:solidFill>
+                  <a:srgbClr val="CBD5E1"/>
+                </a:solidFill>
+              </a:defRPr>
+            </a:pPr>
+            <a:r>
+              <a:t>•  Court-Admissible Chain of Custody: Every observation is backed by a 64-character SHA-256 digest of the unscaled viewport capture.</a:t>
+            </a:r>
+          </a:p>
+          <a:p>
+            <a:pPr>
+              <a:spcAft>
+                <a:spcPts val="600"/>
+              </a:spcAft>
+              <a:defRPr sz="1100">
+                <a:solidFill>
+                  <a:srgbClr val="CBD5E1"/>
+                </a:solidFill>
+              </a:defRPr>
+            </a:pPr>
+            <a:r>
+              <a:t>•  Total Privacy Protection: API credentials stored backend-only; Pillow redaction masks form fields and footers automatically.</a:t>
+            </a:r>
+          </a:p>
+        </p:txBody>
+      </p:sp>
+      <p:sp>
+        <p:nvSpPr>
+          <p:cNvPr id="14" name="Rounded Rectangle 13"/>
+          <p:cNvSpPr/>
+          <p:nvPr/>
+        </p:nvSpPr>
+        <p:spPr>
+          <a:xfrm>
+            <a:off x="6217920" y="2651760"/>
+            <a:ext cx="5212080" cy="3474720"/>
+          </a:xfrm>
+          <a:prstGeom prst="roundRect">
+            <a:avLst/>
+          </a:prstGeom>
+          <a:solidFill>
+            <a:srgbClr val="0E1626"/>
+          </a:solidFill>
+          <a:ln w="19050">
+            <a:solidFill>
+              <a:srgbClr val="3B82F6"/>
+            </a:solidFill>
+          </a:ln>
+        </p:spPr>
+        <p:style>
+          <a:lnRef idx="1">
+            <a:schemeClr val="accent1"/>
+          </a:lnRef>
+          <a:fillRef idx="3">
+            <a:schemeClr val="accent1"/>
+          </a:fillRef>
+          <a:effectRef idx="2">
+            <a:schemeClr val="accent1"/>
+          </a:effectRef>
+          <a:fontRef idx="minor">
+            <a:schemeClr val="lt1"/>
+          </a:fontRef>
+        </p:style>
+        <p:txBody>
+          <a:bodyPr rtlCol="0" anchor="ctr"/>
+          <a:lstStyle/>
+          <a:p>
+            <a:pPr algn="ctr"/>
+          </a:p>
+        </p:txBody>
+      </p:sp>
+      <p:pic>
+        <p:nvPicPr>
+          <p:cNvPr id="15" name="Picture 14" descr="07_lightbox_modal_open_1440x900.png"/>
+          <p:cNvPicPr>
+            <a:picLocks noChangeAspect="1"/>
+          </p:cNvPicPr>
+          <p:nvPr/>
+        </p:nvPicPr>
+        <p:blipFill>
+          <a:blip r:embed="rId2"/>
+          <a:stretch>
+            <a:fillRect/>
+          </a:stretch>
+        </p:blipFill>
+        <p:spPr>
+          <a:xfrm>
+            <a:off x="6291072" y="2724912"/>
+            <a:ext cx="5065776" cy="3328416"/>
+          </a:xfrm>
+          <a:prstGeom prst="rect">
+            <a:avLst/>
+          </a:prstGeom>
+        </p:spPr>
+      </p:pic>
+      <p:sp>
+        <p:nvSpPr>
+          <p:cNvPr id="16" name="TextBox 15"/>
+          <p:cNvSpPr txBox="1"/>
+          <p:nvPr/>
+        </p:nvSpPr>
+        <p:spPr>
+          <a:xfrm>
+            <a:off x="6217920" y="6181344"/>
+            <a:ext cx="5212080" cy="365760"/>
+          </a:xfrm>
+          <a:prstGeom prst="rect">
+            <a:avLst/>
+          </a:prstGeom>
+          <a:noFill/>
+        </p:spPr>
+        <p:txBody>
+          <a:bodyPr wrap="square" tIns="0" lIns="0">
+            <a:spAutoFit/>
+          </a:bodyPr>
+          <a:lstStyle/>
+          <a:p>
+            <a:pPr>
+              <a:defRPr sz="1000" i="1">
+                <a:solidFill>
+                  <a:srgbClr val="94A3B8"/>
+                </a:solidFill>
                 <a:latin typeface="Arial"/>
               </a:defRPr>
             </a:pPr>
             <a:r>
-              <a:t>Admissible Evidence</a:t>
-            </a:r>
-          </a:p>
-          <a:p>
-            <a:pPr>
-              <a:spcAft>
-                <a:spcPts val="600"/>
-              </a:spcAft>
-              <a:defRPr sz="1400" b="1">
-                <a:solidFill>
-                  <a:srgbClr val="FFFFFF"/>
-                </a:solidFill>
-                <a:latin typeface="Arial"/>
-              </a:defRPr>
-            </a:pPr>
-            <a:r>
-              <a:t>Cryptographic Chain of Custody</a:t>
-            </a:r>
-          </a:p>
-          <a:p>
-            <a:pPr>
-              <a:defRPr sz="1100">
-                <a:solidFill>
-                  <a:srgbClr val="CBD5E1"/>
-                </a:solidFill>
-                <a:latin typeface="Arial"/>
-              </a:defRPr>
-            </a:pPr>
-            <a:r>
-              <a:t>Every observed charge is backed by an immutable SHA-256 hashed viewport, transforming anecdotal claims into legally admissible proof.</a:t>
-            </a:r>
-          </a:p>
-        </p:txBody>
-      </p:sp>
-      <p:sp>
-        <p:nvSpPr>
-          <p:cNvPr id="12" name="TextBox 11"/>
+              <a:t>Full-Resolution Lightbox Modal: Unscaled viewport inspection with immutable 64-character SHA-256 cryptographic digest.</a:t>
+            </a:r>
+          </a:p>
+        </p:txBody>
+      </p:sp>
+      <p:sp>
+        <p:nvSpPr>
+          <p:cNvPr id="17" name="TextBox 16"/>
           <p:cNvSpPr txBox="1"/>
           <p:nvPr/>
         </p:nvSpPr>
         <p:spPr>
           <a:xfrm>
-            <a:off x="731520" y="6309360"/>
+            <a:off x="731520" y="6355080"/>
             <a:ext cx="10698480" cy="365760"/>
           </a:xfrm>
           <a:prstGeom prst="rect">
@@ -8894,7 +9173,7 @@
               </a:defRPr>
             </a:pPr>
             <a:r>
-              <a:t>Checkout Radar · AZINHACK 2026 Submission · Slide 8 of 10</a:t>
+              <a:t>Checkout Radar · AZINHACK 2026 Presentation · Slide 8 of 10</a:t>
             </a:r>
           </a:p>
         </p:txBody>
@@ -8969,7 +9248,7 @@
         <p:spPr>
           <a:xfrm>
             <a:off x="731520" y="365760"/>
-            <a:ext cx="10698480" cy="1188720"/>
+            <a:ext cx="10698480" cy="1097280"/>
           </a:xfrm>
           <a:prstGeom prst="rect">
             <a:avLst/>
@@ -8984,7 +9263,7 @@
           <a:p>
             <a:pPr>
               <a:spcAft>
-                <a:spcPts val="400"/>
+                <a:spcPts val="300"/>
               </a:spcAft>
               <a:defRPr sz="1100" b="1">
                 <a:solidFill>
@@ -9000,9 +9279,9 @@
           <a:p>
             <a:pPr>
               <a:spcAft>
-                <a:spcPts val="400"/>
-              </a:spcAft>
-              <a:defRPr sz="2600" b="1">
+                <a:spcPts val="300"/>
+              </a:spcAft>
+              <a:defRPr sz="2500" b="1">
                 <a:solidFill>
                   <a:srgbClr val="FFFFFF"/>
                 </a:solidFill>
@@ -9010,12 +9289,12 @@
               </a:defRPr>
             </a:pPr>
             <a:r>
-              <a:t>Production-Ready Stack with Deterministic Offline Defaults</a:t>
-            </a:r>
-          </a:p>
-          <a:p>
-            <a:pPr>
-              <a:defRPr sz="1300">
+              <a:t>Production-Ready Stack with Zero Setup Friction</a:t>
+            </a:r>
+          </a:p>
+          <a:p>
+            <a:pPr>
+              <a:defRPr sz="1200">
                 <a:solidFill>
                   <a:srgbClr val="94A3B8"/>
                 </a:solidFill>
@@ -9081,8 +9360,8 @@
         </p:nvSpPr>
         <p:spPr>
           <a:xfrm>
-            <a:off x="960120" y="1874520"/>
-            <a:ext cx="2926080" cy="3931920"/>
+            <a:off x="914400" y="1828800"/>
+            <a:ext cx="3017520" cy="4023360"/>
           </a:xfrm>
           <a:prstGeom prst="rect">
             <a:avLst/>
@@ -9097,29 +9376,27 @@
           <a:p>
             <a:pPr>
               <a:spcAft>
-                <a:spcPts val="600"/>
-              </a:spcAft>
-              <a:defRPr sz="1300" b="1">
+                <a:spcPts val="400"/>
+              </a:spcAft>
+              <a:defRPr sz="1100" b="1">
                 <a:solidFill>
                   <a:srgbClr val="38BDF8"/>
                 </a:solidFill>
-                <a:latin typeface="Arial"/>
-              </a:defRPr>
-            </a:pPr>
-            <a:r>
-              <a:t>🚀 One-Command Launch</a:t>
-            </a:r>
-          </a:p>
-          <a:p>
-            <a:pPr>
-              <a:spcAft>
-                <a:spcPts val="1400"/>
-              </a:spcAft>
-              <a:defRPr sz="1800" b="1">
+              </a:defRPr>
+            </a:pPr>
+            <a:r>
+              <a:t>🚀 ONE-COMMAND LAUNCH</a:t>
+            </a:r>
+          </a:p>
+          <a:p>
+            <a:pPr>
+              <a:spcAft>
+                <a:spcPts val="1200"/>
+              </a:spcAft>
+              <a:defRPr sz="1600" b="1">
                 <a:solidFill>
                   <a:srgbClr val="FFFFFF"/>
                 </a:solidFill>
-                <a:latin typeface="Arial"/>
               </a:defRPr>
             </a:pPr>
             <a:r>
@@ -9129,13 +9406,12 @@
           <a:p>
             <a:pPr>
               <a:spcAft>
-                <a:spcPts val="1000"/>
-              </a:spcAft>
-              <a:defRPr sz="1200">
+                <a:spcPts val="800"/>
+              </a:spcAft>
+              <a:defRPr sz="1100">
                 <a:solidFill>
                   <a:srgbClr val="CBD5E1"/>
                 </a:solidFill>
-                <a:latin typeface="Arial"/>
               </a:defRPr>
             </a:pPr>
             <a:r>
@@ -9145,29 +9421,27 @@
           <a:p>
             <a:pPr>
               <a:spcAft>
-                <a:spcPts val="1000"/>
-              </a:spcAft>
-              <a:defRPr sz="1200">
+                <a:spcPts val="800"/>
+              </a:spcAft>
+              <a:defRPr sz="1100">
                 <a:solidFill>
                   <a:srgbClr val="CBD5E1"/>
                 </a:solidFill>
-                <a:latin typeface="Arial"/>
-              </a:defRPr>
-            </a:pPr>
-            <a:r>
-              <a:t>•  Automatic pre-flight diagnostics, .env provisioning, and healthcheck synchronization.</a:t>
-            </a:r>
-          </a:p>
-          <a:p>
-            <a:pPr>
-              <a:spcAft>
-                <a:spcPts val="1000"/>
-              </a:spcAft>
-              <a:defRPr sz="1200">
+              </a:defRPr>
+            </a:pPr>
+            <a:r>
+              <a:t>•  Automatic pre-flight diagnostics, .env provisioning, and healthcheck sync.</a:t>
+            </a:r>
+          </a:p>
+          <a:p>
+            <a:pPr>
+              <a:spcAft>
+                <a:spcPts val="800"/>
+              </a:spcAft>
+              <a:defRPr sz="1100">
                 <a:solidFill>
                   <a:srgbClr val="CBD5E1"/>
                 </a:solidFill>
-                <a:latin typeface="Arial"/>
               </a:defRPr>
             </a:pPr>
             <a:r>
@@ -9177,13 +9451,12 @@
           <a:p>
             <a:pPr>
               <a:spcAft>
-                <a:spcPts val="1000"/>
-              </a:spcAft>
-              <a:defRPr sz="1200">
+                <a:spcPts val="800"/>
+              </a:spcAft>
+              <a:defRPr sz="1100">
                 <a:solidFill>
                   <a:srgbClr val="CBD5E1"/>
                 </a:solidFill>
-                <a:latin typeface="Arial"/>
               </a:defRPr>
             </a:pPr>
             <a:r>
@@ -9245,8 +9518,8 @@
         </p:nvSpPr>
         <p:spPr>
           <a:xfrm>
-            <a:off x="4617720" y="1874520"/>
-            <a:ext cx="2926080" cy="3931920"/>
+            <a:off x="4572000" y="1828800"/>
+            <a:ext cx="3017520" cy="4023360"/>
           </a:xfrm>
           <a:prstGeom prst="rect">
             <a:avLst/>
@@ -9261,45 +9534,42 @@
           <a:p>
             <a:pPr>
               <a:spcAft>
-                <a:spcPts val="600"/>
-              </a:spcAft>
-              <a:defRPr sz="1300" b="1">
+                <a:spcPts val="400"/>
+              </a:spcAft>
+              <a:defRPr sz="1100" b="1">
                 <a:solidFill>
                   <a:srgbClr val="10B981"/>
                 </a:solidFill>
-                <a:latin typeface="Arial"/>
-              </a:defRPr>
-            </a:pPr>
-            <a:r>
-              <a:t>🛡️ Zero-Cost Offline Mock</a:t>
-            </a:r>
-          </a:p>
-          <a:p>
-            <a:pPr>
-              <a:spcAft>
-                <a:spcPts val="1400"/>
-              </a:spcAft>
-              <a:defRPr sz="1800" b="1">
+              </a:defRPr>
+            </a:pPr>
+            <a:r>
+              <a:t>🛡️ DETERMINISTIC MOCK</a:t>
+            </a:r>
+          </a:p>
+          <a:p>
+            <a:pPr>
+              <a:spcAft>
+                <a:spcPts val="1200"/>
+              </a:spcAft>
+              <a:defRPr sz="1600" b="1">
                 <a:solidFill>
                   <a:srgbClr val="FFFFFF"/>
                 </a:solidFill>
-                <a:latin typeface="Arial"/>
-              </a:defRPr>
-            </a:pPr>
-            <a:r>
-              <a:t>100% Deterministic Replay</a:t>
-            </a:r>
-          </a:p>
-          <a:p>
-            <a:pPr>
-              <a:spcAft>
-                <a:spcPts val="1000"/>
-              </a:spcAft>
-              <a:defRPr sz="1200">
+              </a:defRPr>
+            </a:pPr>
+            <a:r>
+              <a:t>100% Free Offline Mode</a:t>
+            </a:r>
+          </a:p>
+          <a:p>
+            <a:pPr>
+              <a:spcAft>
+                <a:spcPts val="800"/>
+              </a:spcAft>
+              <a:defRPr sz="1100">
                 <a:solidFill>
                   <a:srgbClr val="CBD5E1"/>
                 </a:solidFill>
-                <a:latin typeface="Arial"/>
               </a:defRPr>
             </a:pPr>
             <a:r>
@@ -9309,13 +9579,12 @@
           <a:p>
             <a:pPr>
               <a:spcAft>
-                <a:spcPts val="1000"/>
-              </a:spcAft>
-              <a:defRPr sz="1200">
+                <a:spcPts val="800"/>
+              </a:spcAft>
+              <a:defRPr sz="1100">
                 <a:solidFill>
                   <a:srgbClr val="CBD5E1"/>
                 </a:solidFill>
-                <a:latin typeface="Arial"/>
               </a:defRPr>
             </a:pPr>
             <a:r>
@@ -9325,13 +9594,12 @@
           <a:p>
             <a:pPr>
               <a:spcAft>
-                <a:spcPts val="1000"/>
-              </a:spcAft>
-              <a:defRPr sz="1200">
+                <a:spcPts val="800"/>
+              </a:spcAft>
+              <a:defRPr sz="1100">
                 <a:solidFill>
                   <a:srgbClr val="CBD5E1"/>
                 </a:solidFill>
-                <a:latin typeface="Arial"/>
               </a:defRPr>
             </a:pPr>
             <a:r>
@@ -9341,13 +9609,12 @@
           <a:p>
             <a:pPr>
               <a:spcAft>
-                <a:spcPts val="1000"/>
-              </a:spcAft>
-              <a:defRPr sz="1200">
+                <a:spcPts val="800"/>
+              </a:spcAft>
+              <a:defRPr sz="1100">
                 <a:solidFill>
                   <a:srgbClr val="CBD5E1"/>
                 </a:solidFill>
-                <a:latin typeface="Arial"/>
               </a:defRPr>
             </a:pPr>
             <a:r>
@@ -9409,8 +9676,8 @@
         </p:nvSpPr>
         <p:spPr>
           <a:xfrm>
-            <a:off x="8275320" y="1874520"/>
-            <a:ext cx="2926080" cy="3931920"/>
+            <a:off x="8229600" y="1828800"/>
+            <a:ext cx="3017520" cy="4023360"/>
           </a:xfrm>
           <a:prstGeom prst="rect">
             <a:avLst/>
@@ -9425,45 +9692,42 @@
           <a:p>
             <a:pPr>
               <a:spcAft>
-                <a:spcPts val="600"/>
-              </a:spcAft>
-              <a:defRPr sz="1300" b="1">
+                <a:spcPts val="400"/>
+              </a:spcAft>
+              <a:defRPr sz="1100" b="1">
                 <a:solidFill>
                   <a:srgbClr val="3B82F6"/>
                 </a:solidFill>
-                <a:latin typeface="Arial"/>
-              </a:defRPr>
-            </a:pPr>
-            <a:r>
-              <a:t>💰 Cost-Efficient Scale</a:t>
-            </a:r>
-          </a:p>
-          <a:p>
-            <a:pPr>
-              <a:spcAft>
-                <a:spcPts val="1400"/>
-              </a:spcAft>
-              <a:defRPr sz="1800" b="1">
+              </a:defRPr>
+            </a:pPr>
+            <a:r>
+              <a:t>💰 ECONOMICAL SCALE</a:t>
+            </a:r>
+          </a:p>
+          <a:p>
+            <a:pPr>
+              <a:spcAft>
+                <a:spcPts val="1200"/>
+              </a:spcAft>
+              <a:defRPr sz="1600" b="1">
                 <a:solidFill>
                   <a:srgbClr val="FFFFFF"/>
                 </a:solidFill>
-                <a:latin typeface="Arial"/>
-              </a:defRPr>
-            </a:pPr>
-            <a:r>
-              <a:t>Economical Live Execution</a:t>
-            </a:r>
-          </a:p>
-          <a:p>
-            <a:pPr>
-              <a:spcAft>
-                <a:spcPts val="1000"/>
-              </a:spcAft>
-              <a:defRPr sz="1200">
+              </a:defRPr>
+            </a:pPr>
+            <a:r>
+              <a:t>Cost-Efficient Live Runs</a:t>
+            </a:r>
+          </a:p>
+          <a:p>
+            <a:pPr>
+              <a:spcAft>
+                <a:spcPts val="800"/>
+              </a:spcAft>
+              <a:defRPr sz="1100">
                 <a:solidFill>
                   <a:srgbClr val="CBD5E1"/>
                 </a:solidFill>
-                <a:latin typeface="Arial"/>
               </a:defRPr>
             </a:pPr>
             <a:r>
@@ -9473,13 +9737,12 @@
           <a:p>
             <a:pPr>
               <a:spcAft>
-                <a:spcPts val="1000"/>
-              </a:spcAft>
-              <a:defRPr sz="1200">
+                <a:spcPts val="800"/>
+              </a:spcAft>
+              <a:defRPr sz="1100">
                 <a:solidFill>
                   <a:srgbClr val="CBD5E1"/>
                 </a:solidFill>
-                <a:latin typeface="Arial"/>
               </a:defRPr>
             </a:pPr>
             <a:r>
@@ -9489,13 +9752,12 @@
           <a:p>
             <a:pPr>
               <a:spcAft>
-                <a:spcPts val="1000"/>
-              </a:spcAft>
-              <a:defRPr sz="1200">
+                <a:spcPts val="800"/>
+              </a:spcAft>
+              <a:defRPr sz="1100">
                 <a:solidFill>
                   <a:srgbClr val="CBD5E1"/>
                 </a:solidFill>
-                <a:latin typeface="Arial"/>
               </a:defRPr>
             </a:pPr>
             <a:r>
@@ -9512,7 +9774,7 @@
         </p:nvSpPr>
         <p:spPr>
           <a:xfrm>
-            <a:off x="731520" y="6309360"/>
+            <a:off x="731520" y="6355080"/>
             <a:ext cx="10698480" cy="365760"/>
           </a:xfrm>
           <a:prstGeom prst="rect">
@@ -9535,7 +9797,7 @@
               </a:defRPr>
             </a:pPr>
             <a:r>
-              <a:t>Checkout Radar · AZINHACK 2026 Submission · Slide 9 of 10</a:t>
+              <a:t>Checkout Radar · AZINHACK 2026 Presentation · Slide 9 of 10</a:t>
             </a:r>
           </a:p>
         </p:txBody>

</xml_diff>